<commit_message>
Deploy viewer examples from commit 9098becb at 2026/07/01 15:37:49
</commit_message>
<xml_diff>
--- a/viewer-examples/samples/05-preview.pptx
+++ b/viewer-examples/samples/05-preview.pptx
@@ -1579,7 +1579,7 @@
               <c:strCache>
                 <c:ptCount val="1"/>
                 <c:pt idx="0">
-                  <c:v>月活数量</c:v>
+                  <c:v>Monthly Active Users</c:v>
                 </c:pt>
               </c:strCache>
             </c:strRef>
@@ -2228,7 +2228,7 @@
             </a:pPr>
             <a:r>
               <a:rPr lang="zh-CN" altLang="en-US"/>
-              <a:t>问题类型数量统计</a:t>
+              <a:t>Issue Count by Type</a:t>
             </a:r>
           </a:p>
         </c:rich>
@@ -2287,7 +2287,7 @@
               <c:strCache>
                 <c:ptCount val="1"/>
                 <c:pt idx="0">
-                  <c:v>数量</c:v>
+                  <c:v>Count</c:v>
                 </c:pt>
               </c:strCache>
             </c:strRef>
@@ -2527,19 +2527,19 @@
               <c:strCache>
                 <c:ptCount val="5"/>
                 <c:pt idx="0">
-                  <c:v>bug</c:v>
+                  <c:v>Bug</c:v>
                 </c:pt>
                 <c:pt idx="1">
-                  <c:v>操作咨询</c:v>
+                  <c:v>How-to Questions</c:v>
                 </c:pt>
                 <c:pt idx="2">
-                  <c:v>数据问题</c:v>
+                  <c:v>Data Issues</c:v>
                 </c:pt>
                 <c:pt idx="3">
-                  <c:v>优化需求</c:v>
+                  <c:v>Optimization Requests</c:v>
                 </c:pt>
                 <c:pt idx="4">
-                  <c:v>运维支持</c:v>
+                  <c:v>Ops Support</c:v>
                 </c:pt>
               </c:strCache>
             </c:strRef>
@@ -2716,7 +2716,7 @@
             </a:pPr>
             <a:r>
               <a:rPr lang="zh-CN" altLang="en-US"/>
-              <a:t>问题状态数量统计</a:t>
+              <a:t>Issue Count by Status</a:t>
             </a:r>
           </a:p>
         </c:rich>
@@ -2775,7 +2775,7 @@
               <c:strCache>
                 <c:ptCount val="1"/>
                 <c:pt idx="0">
-                  <c:v>数量</c:v>
+                  <c:v>Count</c:v>
                 </c:pt>
               </c:strCache>
             </c:strRef>
@@ -2925,13 +2925,13 @@
               <c:strCache>
                 <c:ptCount val="3"/>
                 <c:pt idx="0">
-                  <c:v>已处理</c:v>
+                  <c:v>Resolved</c:v>
                 </c:pt>
                 <c:pt idx="1">
-                  <c:v>已关闭</c:v>
+                  <c:v>Closed</c:v>
                 </c:pt>
                 <c:pt idx="2">
-                  <c:v>无需处理</c:v>
+                  <c:v>No Action Needed</c:v>
                 </c:pt>
               </c:strCache>
             </c:strRef>
@@ -3469,7 +3469,7 @@
             </a:pPr>
             <a:r>
               <a:rPr lang="zh-CN" altLang="en-US"/>
-              <a:t>运维问题数量统计</a:t>
+              <a:t>Support Issues by Month</a:t>
             </a:r>
           </a:p>
         </c:rich>
@@ -3515,7 +3515,7 @@
               <c:strCache>
                 <c:ptCount val="1"/>
                 <c:pt idx="0">
-                  <c:v>bug</c:v>
+                  <c:v>Bug</c:v>
                 </c:pt>
               </c:strCache>
             </c:strRef>
@@ -3651,7 +3651,7 @@
               <c:strCache>
                 <c:ptCount val="1"/>
                 <c:pt idx="0">
-                  <c:v>操作咨询</c:v>
+                  <c:v>How-to Questions</c:v>
                 </c:pt>
               </c:strCache>
             </c:strRef>
@@ -3787,7 +3787,7 @@
               <c:strCache>
                 <c:ptCount val="1"/>
                 <c:pt idx="0">
-                  <c:v>数据问题</c:v>
+                  <c:v>Data Issues</c:v>
                 </c:pt>
               </c:strCache>
             </c:strRef>
@@ -3922,7 +3922,7 @@
               <c:strCache>
                 <c:ptCount val="1"/>
                 <c:pt idx="0">
-                  <c:v>优化需求</c:v>
+                  <c:v>Optimization Requests</c:v>
                 </c:pt>
               </c:strCache>
             </c:strRef>
@@ -4057,7 +4057,7 @@
               <c:strCache>
                 <c:ptCount val="1"/>
                 <c:pt idx="0">
-                  <c:v>运维支持</c:v>
+                  <c:v>Ops Support</c:v>
                 </c:pt>
               </c:strCache>
             </c:strRef>
@@ -4192,7 +4192,7 @@
               <c:strCache>
                 <c:ptCount val="1"/>
                 <c:pt idx="0">
-                  <c:v>总计</c:v>
+                  <c:v>Total</c:v>
                 </c:pt>
               </c:strCache>
             </c:strRef>
@@ -9871,7 +9871,7 @@
           <a:p>
             <a:fld id="{5BCAD085-E8A6-8845-BD4E-CB4CCA059FC4}" type="datetimeFigureOut">
               <a:rPr lang="en-US" smtClean="0"/>
-              <a:t>4/11/26</a:t>
+              <a:t>7/1/26</a:t>
             </a:fld>
             <a:endParaRPr lang="en-US"/>
           </a:p>
@@ -10039,7 +10039,7 @@
           <a:p>
             <a:fld id="{5BCAD085-E8A6-8845-BD4E-CB4CCA059FC4}" type="datetimeFigureOut">
               <a:rPr lang="en-US" smtClean="0"/>
-              <a:t>4/11/26</a:t>
+              <a:t>7/1/26</a:t>
             </a:fld>
             <a:endParaRPr lang="en-US"/>
           </a:p>
@@ -10217,7 +10217,7 @@
           <a:p>
             <a:fld id="{5BCAD085-E8A6-8845-BD4E-CB4CCA059FC4}" type="datetimeFigureOut">
               <a:rPr lang="en-US" smtClean="0"/>
-              <a:t>4/11/26</a:t>
+              <a:t>7/1/26</a:t>
             </a:fld>
             <a:endParaRPr lang="en-US"/>
           </a:p>
@@ -10385,7 +10385,7 @@
           <a:p>
             <a:fld id="{5BCAD085-E8A6-8845-BD4E-CB4CCA059FC4}" type="datetimeFigureOut">
               <a:rPr lang="en-US" smtClean="0"/>
-              <a:t>4/11/26</a:t>
+              <a:t>7/1/26</a:t>
             </a:fld>
             <a:endParaRPr lang="en-US"/>
           </a:p>
@@ -10630,7 +10630,7 @@
           <a:p>
             <a:fld id="{5BCAD085-E8A6-8845-BD4E-CB4CCA059FC4}" type="datetimeFigureOut">
               <a:rPr lang="en-US" smtClean="0"/>
-              <a:t>4/11/26</a:t>
+              <a:t>7/1/26</a:t>
             </a:fld>
             <a:endParaRPr lang="en-US"/>
           </a:p>
@@ -10915,7 +10915,7 @@
           <a:p>
             <a:fld id="{5BCAD085-E8A6-8845-BD4E-CB4CCA059FC4}" type="datetimeFigureOut">
               <a:rPr lang="en-US" smtClean="0"/>
-              <a:t>4/11/26</a:t>
+              <a:t>7/1/26</a:t>
             </a:fld>
             <a:endParaRPr lang="en-US"/>
           </a:p>
@@ -11334,7 +11334,7 @@
           <a:p>
             <a:fld id="{5BCAD085-E8A6-8845-BD4E-CB4CCA059FC4}" type="datetimeFigureOut">
               <a:rPr lang="en-US" smtClean="0"/>
-              <a:t>4/11/26</a:t>
+              <a:t>7/1/26</a:t>
             </a:fld>
             <a:endParaRPr lang="en-US"/>
           </a:p>
@@ -11451,7 +11451,7 @@
           <a:p>
             <a:fld id="{5BCAD085-E8A6-8845-BD4E-CB4CCA059FC4}" type="datetimeFigureOut">
               <a:rPr lang="en-US" smtClean="0"/>
-              <a:t>4/11/26</a:t>
+              <a:t>7/1/26</a:t>
             </a:fld>
             <a:endParaRPr lang="en-US"/>
           </a:p>
@@ -11546,7 +11546,7 @@
           <a:p>
             <a:fld id="{5BCAD085-E8A6-8845-BD4E-CB4CCA059FC4}" type="datetimeFigureOut">
               <a:rPr lang="en-US" smtClean="0"/>
-              <a:t>4/11/26</a:t>
+              <a:t>7/1/26</a:t>
             </a:fld>
             <a:endParaRPr lang="en-US"/>
           </a:p>
@@ -11821,7 +11821,7 @@
           <a:p>
             <a:fld id="{5BCAD085-E8A6-8845-BD4E-CB4CCA059FC4}" type="datetimeFigureOut">
               <a:rPr lang="en-US" smtClean="0"/>
-              <a:t>4/11/26</a:t>
+              <a:t>7/1/26</a:t>
             </a:fld>
             <a:endParaRPr lang="en-US"/>
           </a:p>
@@ -12073,7 +12073,7 @@
           <a:p>
             <a:fld id="{5BCAD085-E8A6-8845-BD4E-CB4CCA059FC4}" type="datetimeFigureOut">
               <a:rPr lang="en-US" smtClean="0"/>
-              <a:t>4/11/26</a:t>
+              <a:t>7/1/26</a:t>
             </a:fld>
             <a:endParaRPr lang="en-US"/>
           </a:p>
@@ -12284,7 +12284,7 @@
           <a:p>
             <a:fld id="{5BCAD085-E8A6-8845-BD4E-CB4CCA059FC4}" type="datetimeFigureOut">
               <a:rPr lang="en-US" smtClean="0"/>
-              <a:t>4/11/26</a:t>
+              <a:t>7/1/26</a:t>
             </a:fld>
             <a:endParaRPr lang="en-US"/>
           </a:p>
@@ -13159,50 +13159,6 @@
       </p:grpSpPr>
       <p:sp>
         <p:nvSpPr>
-          <p:cNvPr id="2" name="Rectangle 1"/>
-          <p:cNvSpPr/>
-          <p:nvPr/>
-        </p:nvSpPr>
-        <p:spPr>
-          <a:xfrm>
-            <a:off x="0" y="0"/>
-            <a:ext cx="9144000" cy="54864"/>
-          </a:xfrm>
-          <a:prstGeom prst="rect">
-            <a:avLst/>
-          </a:prstGeom>
-          <a:solidFill>
-            <a:srgbClr val="E8651A"/>
-          </a:solidFill>
-          <a:ln>
-            <a:noFill/>
-          </a:ln>
-        </p:spPr>
-        <p:style>
-          <a:lnRef idx="1">
-            <a:schemeClr val="accent1"/>
-          </a:lnRef>
-          <a:fillRef idx="3">
-            <a:schemeClr val="accent1"/>
-          </a:fillRef>
-          <a:effectRef idx="2">
-            <a:schemeClr val="accent1"/>
-          </a:effectRef>
-          <a:fontRef idx="minor">
-            <a:schemeClr val="lt1"/>
-          </a:fontRef>
-        </p:style>
-        <p:txBody>
-          <a:bodyPr rtlCol="0" anchor="ctr"/>
-          <a:lstStyle/>
-          <a:p>
-            <a:pPr algn="ctr"/>
-            <a:endParaRPr/>
-          </a:p>
-        </p:txBody>
-      </p:sp>
-      <p:sp>
-        <p:nvSpPr>
           <p:cNvPr id="3" name="Oval 2"/>
           <p:cNvSpPr/>
           <p:nvPr/>
@@ -13281,7 +13237,7 @@
                   <a:srgbClr val="2D3436"/>
                 </a:solidFill>
               </a:rPr>
-              <a:t>超链接 tooltip / action</a:t>
+              <a:t>Links</a:t>
             </a:r>
           </a:p>
         </p:txBody>
@@ -13314,7 +13270,7 @@
                   <a:srgbClr val="7F8C8D"/>
                 </a:solidFill>
               </a:rPr>
-              <a:t>验证 tooltip、hlinkMouseOver、ppaction://hlinksldjump</a:t>
+              <a:t>Tests tooltip, hlinkMouseOver, and ppaction://hlinksldjump</a:t>
             </a:r>
           </a:p>
         </p:txBody>
@@ -13483,9 +13439,9 @@
                 <a:solidFill>
                   <a:srgbClr val="D35400"/>
                 </a:solidFill>
-                <a:hlinkClick r:id="rId2" tooltip="点击访问 GitHub 官网"/>
+                <a:hlinkClick r:id="rId2" tooltip="Open GitHub"/>
               </a:rPr>
-              <a:t>Web 链接 + tooltip</a:t>
+              <a:t>Web link + tooltip</a:t>
             </a:r>
           </a:p>
         </p:txBody>
@@ -13552,7 +13508,7 @@
                   <a:srgbClr val="E8651A"/>
                 </a:solidFill>
               </a:rPr>
-              <a:t>tooltip: "点击访问 GitHub 官网"</a:t>
+              <a:t>tooltip: "Open GitHub"</a:t>
             </a:r>
           </a:p>
         </p:txBody>
@@ -13679,7 +13635,7 @@
                 </a:solidFill>
                 <a:hlinkClick r:id="rId3"/>
               </a:rPr>
-              <a:t>Web 链接无 tooltip</a:t>
+              <a:t>Web link without tooltip</a:t>
             </a:r>
           </a:p>
         </p:txBody>
@@ -13837,9 +13793,9 @@
                 <a:solidFill>
                   <a:srgbClr val="D35400"/>
                 </a:solidFill>
-                <a:hlinkClick r:id="rId4" tooltip="鼠标悬停时应显示此提示"/>
+                <a:hlinkClick r:id="rId4" tooltip="This hint should appear on hover"/>
               </a:rPr>
-              <a:t>带 tooltip 的链接</a:t>
+              <a:t>Link with tooltip</a:t>
             </a:r>
           </a:p>
         </p:txBody>
@@ -13906,7 +13862,7 @@
                   <a:srgbClr val="E8651A"/>
                 </a:solidFill>
               </a:rPr>
-              <a:t>tooltip: "鼠标悬停时应显示此提示"</a:t>
+              <a:t>tooltip: "This hint should appear on hover"</a:t>
             </a:r>
           </a:p>
         </p:txBody>
@@ -14031,9 +13987,9 @@
                 <a:solidFill>
                   <a:srgbClr val="C0392B"/>
                 </a:solidFill>
-                <a:hlinkClick r:id="rId5" action="ppaction://hlinksldjump" tooltip="跳转到第 1 页"/>
+                <a:hlinkClick r:id="rId5" action="ppaction://hlinksldjump" tooltip="Jump to Slide 1"/>
               </a:rPr>
-              <a:t>幻灯片跳转 (ppaction)</a:t>
+              <a:t>Slide jump (ppaction)</a:t>
             </a:r>
           </a:p>
         </p:txBody>
@@ -14066,7 +14022,7 @@
                   <a:srgbClr val="7F8C8D"/>
                 </a:solidFill>
               </a:rPr>
-              <a:t>跳转到第 1 页</a:t>
+              <a:t>Jump to Slide 1</a:t>
             </a:r>
           </a:p>
         </p:txBody>
@@ -14100,7 +14056,7 @@
                   <a:srgbClr val="E8651A"/>
                 </a:solidFill>
               </a:rPr>
-              <a:t>tooltip: "跳转到第 1 页"</a:t>
+              <a:t>tooltip: "Jump to Slide 1"</a:t>
             </a:r>
           </a:p>
         </p:txBody>
@@ -14225,9 +14181,9 @@
                 <a:solidFill>
                   <a:srgbClr val="27AE60"/>
                 </a:solidFill>
-                <a:hlinkMouseOver r:id="rId6" tooltip="这是鼠标悬停提示文本"/>
+                <a:hlinkMouseOver r:id="rId6" tooltip="This is hover-triggered tooltip text"/>
               </a:rPr>
-              <a:t>鼠标悬停 (hlinkMouseOver)</a:t>
+              <a:t>Mouse hover (hlinkMouseOver)</a:t>
             </a:r>
           </a:p>
         </p:txBody>
@@ -14260,7 +14216,7 @@
                   <a:srgbClr val="7F8C8D"/>
                 </a:solidFill>
               </a:rPr>
-              <a:t>这是鼠标悬停提示文本</a:t>
+              <a:t>This is hover-triggered tooltip text</a:t>
             </a:r>
           </a:p>
         </p:txBody>
@@ -14294,7 +14250,7 @@
                   <a:srgbClr val="E8651A"/>
                 </a:solidFill>
               </a:rPr>
-              <a:t>tooltip: "这是鼠标悬停提示文本"</a:t>
+              <a:t>tooltip: "This is hover-triggered tooltip text"</a:t>
             </a:r>
           </a:p>
         </p:txBody>
@@ -14332,50 +14288,6 @@
           <a:chExt cx="0" cy="0"/>
         </a:xfrm>
       </p:grpSpPr>
-      <p:sp>
-        <p:nvSpPr>
-          <p:cNvPr id="2" name="Rectangle 1"/>
-          <p:cNvSpPr/>
-          <p:nvPr/>
-        </p:nvSpPr>
-        <p:spPr>
-          <a:xfrm>
-            <a:off x="0" y="0"/>
-            <a:ext cx="9144000" cy="54864"/>
-          </a:xfrm>
-          <a:prstGeom prst="rect">
-            <a:avLst/>
-          </a:prstGeom>
-          <a:solidFill>
-            <a:srgbClr val="E8651A"/>
-          </a:solidFill>
-          <a:ln>
-            <a:noFill/>
-          </a:ln>
-        </p:spPr>
-        <p:style>
-          <a:lnRef idx="1">
-            <a:schemeClr val="accent1"/>
-          </a:lnRef>
-          <a:fillRef idx="3">
-            <a:schemeClr val="accent1"/>
-          </a:fillRef>
-          <a:effectRef idx="2">
-            <a:schemeClr val="accent1"/>
-          </a:effectRef>
-          <a:fontRef idx="minor">
-            <a:schemeClr val="lt1"/>
-          </a:fontRef>
-        </p:style>
-        <p:txBody>
-          <a:bodyPr rtlCol="0" anchor="ctr"/>
-          <a:lstStyle/>
-          <a:p>
-            <a:pPr algn="ctr"/>
-            <a:endParaRPr/>
-          </a:p>
-        </p:txBody>
-      </p:sp>
       <p:sp>
         <p:nvSpPr>
           <p:cNvPr id="3" name="Oval 2"/>
@@ -14456,7 +14368,7 @@
                   <a:srgbClr val="2D3436"/>
                 </a:solidFill>
               </a:rPr>
-              <a:t>Tab Stops 制表位</a:t>
+              <a:t>Tab Stops</a:t>
             </a:r>
           </a:p>
         </p:txBody>
@@ -14489,7 +14401,7 @@
                   <a:srgbClr val="7F8C8D"/>
                 </a:solidFill>
               </a:rPr>
-              <a:t>验证 a:tabLst / a:tab 解析（left / center / right / decimal）</a:t>
+              <a:t>Tests a:tabLst / a:tab parsing (left / center / right / decimal)</a:t>
             </a:r>
           </a:p>
         </p:txBody>
@@ -14566,7 +14478,7 @@
                   <a:srgbClr val="E8651A"/>
                 </a:solidFill>
               </a:rPr>
-              <a:t>● 商品价目表（Tab 对齐）</a:t>
+              <a:t>● Product Price List (tab-aligned)</a:t>
             </a:r>
           </a:p>
         </p:txBody>
@@ -14652,7 +14564,7 @@
                   <a:srgbClr val="E8651A"/>
                 </a:solidFill>
               </a:rPr>
-              <a:t>商品名称</a:t>
+              <a:t>Product</a:t>
             </a:r>
             <a:r>
               <a:rPr sz="1300" b="1" dirty="0">
@@ -14668,7 +14580,7 @@
                   <a:srgbClr val="E8651A"/>
                 </a:solidFill>
               </a:rPr>
-              <a:t>单价</a:t>
+              <a:t>Unit Price</a:t>
             </a:r>
             <a:r>
               <a:rPr sz="1300" b="1" dirty="0">
@@ -14684,7 +14596,7 @@
                   <a:srgbClr val="E8651A"/>
                 </a:solidFill>
               </a:rPr>
-              <a:t>数量</a:t>
+              <a:t>Qty</a:t>
             </a:r>
             <a:r>
               <a:rPr sz="1300" b="1" dirty="0">
@@ -14700,7 +14612,7 @@
                   <a:srgbClr val="E8651A"/>
                 </a:solidFill>
               </a:rPr>
-              <a:t>小计</a:t>
+              <a:t>Subtotal</a:t>
             </a:r>
             <a:endParaRPr sz="1300" b="1" dirty="0">
               <a:solidFill>
@@ -14732,7 +14644,7 @@
                   <a:srgbClr val="2D3436"/>
                 </a:solidFill>
               </a:rPr>
-              <a:t>MacBook Pro 14"	¥15,999.00	1	¥15,999.00</a:t>
+              <a:t>MacBook Pro 14"	$1,999.00	1	$1,999.00</a:t>
             </a:r>
           </a:p>
           <a:p>
@@ -14749,7 +14661,7 @@
                   <a:srgbClr val="2D3436"/>
                 </a:solidFill>
               </a:rPr>
-              <a:t>Magic Keyboard	¥999.00	2	¥1,998.00</a:t>
+              <a:t>Magic Keyboard	$129.00	2	$258.00</a:t>
             </a:r>
           </a:p>
           <a:p>
@@ -14774,7 +14686,7 @@
                   <a:srgbClr val="2D3436"/>
                 </a:solidFill>
               </a:rPr>
-              <a:t> Pro	¥1,899.00	3	¥5,697.00</a:t>
+              <a:t> Pro	$249.00	3	$747.00</a:t>
             </a:r>
           </a:p>
           <a:p>
@@ -14791,7 +14703,7 @@
                   <a:srgbClr val="2D3436"/>
                 </a:solidFill>
               </a:rPr>
-              <a:t>Studio Display	¥11,499.00	1	¥11,499.00</a:t>
+              <a:t>Studio Display	$1,599.00	1	$1,599.00</a:t>
             </a:r>
           </a:p>
           <a:p>
@@ -14816,7 +14728,7 @@
                   <a:srgbClr val="2D3436"/>
                 </a:solidFill>
               </a:rPr>
-              <a:t>数据线</a:t>
+              <a:t>Cable</a:t>
             </a:r>
             <a:r>
               <a:rPr sz="1100" dirty="0">
@@ -14824,7 +14736,7 @@
                   <a:srgbClr val="2D3436"/>
                 </a:solidFill>
               </a:rPr>
-              <a:t>	¥149.00	5	¥745.00</a:t>
+              <a:t>	$19.00	5	$95.00</a:t>
             </a:r>
           </a:p>
           <a:p>
@@ -14851,7 +14763,7 @@
                   <a:srgbClr val="E8651A"/>
                 </a:solidFill>
               </a:rPr>
-              <a:t>合计</a:t>
+              <a:t>Total</a:t>
             </a:r>
             <a:r>
               <a:rPr sz="1400" b="1">
@@ -14859,7 +14771,7 @@
                   <a:srgbClr val="E8651A"/>
                 </a:solidFill>
               </a:rPr>
-              <a:t>			¥35,938.00</a:t>
+              <a:t>			$4,698.00</a:t>
             </a:r>
           </a:p>
         </p:txBody>
@@ -14897,50 +14809,6 @@
           <a:chExt cx="0" cy="0"/>
         </a:xfrm>
       </p:grpSpPr>
-      <p:sp>
-        <p:nvSpPr>
-          <p:cNvPr id="2" name="Rectangle 1"/>
-          <p:cNvSpPr/>
-          <p:nvPr/>
-        </p:nvSpPr>
-        <p:spPr>
-          <a:xfrm>
-            <a:off x="0" y="0"/>
-            <a:ext cx="9144000" cy="54864"/>
-          </a:xfrm>
-          <a:prstGeom prst="rect">
-            <a:avLst/>
-          </a:prstGeom>
-          <a:solidFill>
-            <a:srgbClr val="E8651A"/>
-          </a:solidFill>
-          <a:ln>
-            <a:noFill/>
-          </a:ln>
-        </p:spPr>
-        <p:style>
-          <a:lnRef idx="1">
-            <a:schemeClr val="accent1"/>
-          </a:lnRef>
-          <a:fillRef idx="3">
-            <a:schemeClr val="accent1"/>
-          </a:fillRef>
-          <a:effectRef idx="2">
-            <a:schemeClr val="accent1"/>
-          </a:effectRef>
-          <a:fontRef idx="minor">
-            <a:schemeClr val="lt1"/>
-          </a:fontRef>
-        </p:style>
-        <p:txBody>
-          <a:bodyPr rtlCol="0" anchor="ctr"/>
-          <a:lstStyle/>
-          <a:p>
-            <a:pPr algn="ctr"/>
-            <a:endParaRPr/>
-          </a:p>
-        </p:txBody>
-      </p:sp>
       <p:sp>
         <p:nvSpPr>
           <p:cNvPr id="3" name="Oval 2"/>
@@ -15014,14 +14882,9 @@
           </a:bodyPr>
           <a:lstStyle/>
           <a:p>
-            <a:pPr algn="l"/>
-            <a:r>
-              <a:rPr sz="2600" b="1">
-                <a:solidFill>
-                  <a:srgbClr val="2D3436"/>
-                </a:solidFill>
-              </a:rPr>
-              <a:t>图案填充 (Pattern Fill)</a:t>
+            <a:r>
+              <a:rPr lang="en-US"/>
+              <a:t>Pattern Fill</a:t>
             </a:r>
           </a:p>
         </p:txBody>
@@ -15049,12 +14912,8 @@
           <a:lstStyle/>
           <a:p>
             <a:r>
-              <a:rPr sz="1100" i="1">
-                <a:solidFill>
-                  <a:srgbClr val="7F8C8D"/>
-                </a:solidFill>
-              </a:rPr>
-              <a:t>验证 a:pattFill 渲染 — 约 50 种 OOXML 预设图案</a:t>
+              <a:rPr lang="en-US"/>
+              <a:t>Tests a:pattFill rendering across common OOXML preset patterns</a:t>
             </a:r>
           </a:p>
         </p:txBody>
@@ -15433,7 +15292,7 @@
         <p:spPr>
           <a:xfrm>
             <a:off x="411480" y="3310128"/>
-            <a:ext cx="1920240" cy="228600"/>
+            <a:ext cx="705642" cy="230832"/>
           </a:xfrm>
           <a:prstGeom prst="rect">
             <a:avLst/>
@@ -15446,14 +15305,21 @@
           </a:bodyPr>
           <a:lstStyle/>
           <a:p>
-            <a:pPr algn="ctr"/>
-            <a:r>
-              <a:rPr sz="750">
-                <a:solidFill>
-                  <a:srgbClr val="7F8C8D"/>
-                </a:solidFill>
-              </a:rPr>
-              <a:t>水平线 (horz)</a:t>
+            <a:r>
+              <a:rPr lang="en-US" sz="900" dirty="0" err="1"/>
+              <a:t>Horz</a:t>
+            </a:r>
+            <a:r>
+              <a:rPr lang="en-US" sz="900" dirty="0"/>
+              <a:t> (</a:t>
+            </a:r>
+            <a:r>
+              <a:rPr lang="en-US" sz="900" dirty="0" err="1"/>
+              <a:t>horz</a:t>
+            </a:r>
+            <a:r>
+              <a:rPr lang="en-US" sz="900" dirty="0"/>
+              <a:t>)</a:t>
             </a:r>
           </a:p>
         </p:txBody>
@@ -15504,7 +15370,7 @@
         <p:spPr>
           <a:xfrm>
             <a:off x="2560320" y="3310128"/>
-            <a:ext cx="1920240" cy="228600"/>
+            <a:ext cx="671979" cy="230832"/>
           </a:xfrm>
           <a:prstGeom prst="rect">
             <a:avLst/>
@@ -15517,14 +15383,9 @@
           </a:bodyPr>
           <a:lstStyle/>
           <a:p>
-            <a:pPr algn="ctr"/>
-            <a:r>
-              <a:rPr sz="750">
-                <a:solidFill>
-                  <a:srgbClr val="7F8C8D"/>
-                </a:solidFill>
-              </a:rPr>
-              <a:t>垂直线 (vert)</a:t>
+            <a:r>
+              <a:rPr lang="en-US" sz="900" dirty="0"/>
+              <a:t>Vert (vert)</a:t>
             </a:r>
           </a:p>
         </p:txBody>
@@ -15575,7 +15436,7 @@
         <p:spPr>
           <a:xfrm>
             <a:off x="4709160" y="3310128"/>
-            <a:ext cx="1920240" cy="228600"/>
+            <a:ext cx="522900" cy="230832"/>
           </a:xfrm>
           <a:prstGeom prst="rect">
             <a:avLst/>
@@ -15588,14 +15449,9 @@
           </a:bodyPr>
           <a:lstStyle/>
           <a:p>
-            <a:pPr algn="ctr"/>
-            <a:r>
-              <a:rPr sz="750">
-                <a:solidFill>
-                  <a:srgbClr val="7F8C8D"/>
-                </a:solidFill>
-              </a:rPr>
-              <a:t>↘ 对角 (dnDiag)</a:t>
+            <a:r>
+              <a:rPr lang="en-US" sz="900"/>
+              <a:t>DnDiag</a:t>
             </a:r>
           </a:p>
         </p:txBody>
@@ -15646,7 +15502,7 @@
         <p:spPr>
           <a:xfrm>
             <a:off x="6858000" y="3310128"/>
-            <a:ext cx="1920240" cy="228600"/>
+            <a:ext cx="526106" cy="230832"/>
           </a:xfrm>
           <a:prstGeom prst="rect">
             <a:avLst/>
@@ -15659,14 +15515,9 @@
           </a:bodyPr>
           <a:lstStyle/>
           <a:p>
-            <a:pPr algn="ctr"/>
-            <a:r>
-              <a:rPr sz="750">
-                <a:solidFill>
-                  <a:srgbClr val="7F8C8D"/>
-                </a:solidFill>
-              </a:rPr>
-              <a:t>↗ 对角 (upDiag)</a:t>
+            <a:r>
+              <a:rPr lang="en-US" sz="900"/>
+              <a:t>UpDiag</a:t>
             </a:r>
           </a:p>
         </p:txBody>
@@ -15704,7 +15555,7 @@
           <a:lstStyle/>
           <a:p>
             <a:pPr algn="ctr"/>
-            <a:endParaRPr/>
+            <a:endParaRPr sz="900"/>
           </a:p>
         </p:txBody>
       </p:sp>
@@ -15717,7 +15568,7 @@
         <p:spPr>
           <a:xfrm>
             <a:off x="411480" y="4544568"/>
-            <a:ext cx="1920240" cy="228600"/>
+            <a:ext cx="609462" cy="230832"/>
           </a:xfrm>
           <a:prstGeom prst="rect">
             <a:avLst/>
@@ -15730,15 +15581,11 @@
           </a:bodyPr>
           <a:lstStyle/>
           <a:p>
-            <a:pPr algn="ctr"/>
-            <a:r>
-              <a:rPr sz="750">
-                <a:solidFill>
-                  <a:srgbClr val="7F8C8D"/>
-                </a:solidFill>
-              </a:rPr>
-              <a:t>浅↘ (ltDnDiag)</a:t>
-            </a:r>
+            <a:r>
+              <a:rPr lang="en-US" sz="900" dirty="0" err="1"/>
+              <a:t>LtDnDiag</a:t>
+            </a:r>
+            <a:endParaRPr lang="en-US" sz="900" dirty="0"/>
           </a:p>
         </p:txBody>
       </p:sp>
@@ -15775,7 +15622,7 @@
           <a:lstStyle/>
           <a:p>
             <a:pPr algn="ctr"/>
-            <a:endParaRPr/>
+            <a:endParaRPr sz="900"/>
           </a:p>
         </p:txBody>
       </p:sp>
@@ -15788,7 +15635,7 @@
         <p:spPr>
           <a:xfrm>
             <a:off x="2560320" y="4544568"/>
-            <a:ext cx="1920240" cy="228600"/>
+            <a:ext cx="612668" cy="230832"/>
           </a:xfrm>
           <a:prstGeom prst="rect">
             <a:avLst/>
@@ -15801,15 +15648,11 @@
           </a:bodyPr>
           <a:lstStyle/>
           <a:p>
-            <a:pPr algn="ctr"/>
-            <a:r>
-              <a:rPr sz="750">
-                <a:solidFill>
-                  <a:srgbClr val="7F8C8D"/>
-                </a:solidFill>
-              </a:rPr>
-              <a:t>浅↗ (ltUpDiag)</a:t>
-            </a:r>
+            <a:r>
+              <a:rPr lang="en-US" sz="900" dirty="0" err="1"/>
+              <a:t>LtUpDiag</a:t>
+            </a:r>
+            <a:endParaRPr lang="en-US" sz="900" dirty="0"/>
           </a:p>
         </p:txBody>
       </p:sp>
@@ -15846,7 +15689,7 @@
           <a:lstStyle/>
           <a:p>
             <a:pPr algn="ctr"/>
-            <a:endParaRPr/>
+            <a:endParaRPr sz="900"/>
           </a:p>
         </p:txBody>
       </p:sp>
@@ -15859,7 +15702,7 @@
         <p:spPr>
           <a:xfrm>
             <a:off x="4709160" y="4544568"/>
-            <a:ext cx="1920240" cy="228600"/>
+            <a:ext cx="436338" cy="230832"/>
           </a:xfrm>
           <a:prstGeom prst="rect">
             <a:avLst/>
@@ -15872,14 +15715,9 @@
           </a:bodyPr>
           <a:lstStyle/>
           <a:p>
-            <a:pPr algn="ctr"/>
-            <a:r>
-              <a:rPr sz="750">
-                <a:solidFill>
-                  <a:srgbClr val="7F8C8D"/>
-                </a:solidFill>
-              </a:rPr>
-              <a:t>十字 (cross)</a:t>
+            <a:r>
+              <a:rPr lang="en-US" sz="900" dirty="0"/>
+              <a:t>Cross</a:t>
             </a:r>
           </a:p>
         </p:txBody>
@@ -15917,7 +15755,7 @@
           <a:lstStyle/>
           <a:p>
             <a:pPr algn="ctr"/>
-            <a:endParaRPr/>
+            <a:endParaRPr sz="900"/>
           </a:p>
         </p:txBody>
       </p:sp>
@@ -15930,7 +15768,7 @@
         <p:spPr>
           <a:xfrm>
             <a:off x="6858000" y="4544568"/>
-            <a:ext cx="1920240" cy="228600"/>
+            <a:ext cx="643125" cy="230832"/>
           </a:xfrm>
           <a:prstGeom prst="rect">
             <a:avLst/>
@@ -15943,15 +15781,11 @@
           </a:bodyPr>
           <a:lstStyle/>
           <a:p>
-            <a:pPr algn="ctr"/>
-            <a:r>
-              <a:rPr sz="750">
-                <a:solidFill>
-                  <a:srgbClr val="7F8C8D"/>
-                </a:solidFill>
-              </a:rPr>
-              <a:t>斜十字 (diagCross)</a:t>
-            </a:r>
+            <a:r>
+              <a:rPr lang="en-US" sz="900" dirty="0" err="1"/>
+              <a:t>DiagCross</a:t>
+            </a:r>
+            <a:endParaRPr lang="en-US" sz="900" dirty="0"/>
           </a:p>
         </p:txBody>
       </p:sp>
@@ -15993,50 +15827,6 @@
       </p:grpSpPr>
       <p:sp>
         <p:nvSpPr>
-          <p:cNvPr id="2" name="Rectangle 1"/>
-          <p:cNvSpPr/>
-          <p:nvPr/>
-        </p:nvSpPr>
-        <p:spPr>
-          <a:xfrm>
-            <a:off x="0" y="0"/>
-            <a:ext cx="9144000" cy="54864"/>
-          </a:xfrm>
-          <a:prstGeom prst="rect">
-            <a:avLst/>
-          </a:prstGeom>
-          <a:solidFill>
-            <a:srgbClr val="E8651A"/>
-          </a:solidFill>
-          <a:ln>
-            <a:noFill/>
-          </a:ln>
-        </p:spPr>
-        <p:style>
-          <a:lnRef idx="1">
-            <a:schemeClr val="accent1"/>
-          </a:lnRef>
-          <a:fillRef idx="3">
-            <a:schemeClr val="accent1"/>
-          </a:fillRef>
-          <a:effectRef idx="2">
-            <a:schemeClr val="accent1"/>
-          </a:effectRef>
-          <a:fontRef idx="minor">
-            <a:schemeClr val="lt1"/>
-          </a:fontRef>
-        </p:style>
-        <p:txBody>
-          <a:bodyPr rtlCol="0" anchor="ctr"/>
-          <a:lstStyle/>
-          <a:p>
-            <a:pPr algn="ctr"/>
-            <a:endParaRPr/>
-          </a:p>
-        </p:txBody>
-      </p:sp>
-      <p:sp>
-        <p:nvSpPr>
           <p:cNvPr id="3" name="Oval 2"/>
           <p:cNvSpPr/>
           <p:nvPr/>
@@ -16108,14 +15898,9 @@
           </a:bodyPr>
           <a:lstStyle/>
           <a:p>
-            <a:pPr algn="l"/>
-            <a:r>
-              <a:rPr sz="2600" b="1">
-                <a:solidFill>
-                  <a:srgbClr val="2D3436"/>
-                </a:solidFill>
-              </a:rPr>
-              <a:t>过渡动画 · 续</a:t>
+            <a:r>
+              <a:rPr lang="en-US"/>
+              <a:t>Transition Animation · Continued</a:t>
             </a:r>
           </a:p>
         </p:txBody>
@@ -16129,7 +15914,7 @@
         <p:spPr>
           <a:xfrm>
             <a:off x="1051560" y="658368"/>
-            <a:ext cx="7315200" cy="292608"/>
+            <a:ext cx="3156185" cy="276999"/>
           </a:xfrm>
           <a:prstGeom prst="rect">
             <a:avLst/>
@@ -16143,12 +15928,8 @@
           <a:lstStyle/>
           <a:p>
             <a:r>
-              <a:rPr sz="1100" i="1">
-                <a:solidFill>
-                  <a:srgbClr val="7F8C8D"/>
-                </a:solidFill>
-              </a:rPr>
-              <a:t>本页: push 推入效果（从左侧进入）</a:t>
+              <a:rPr lang="en-US" sz="1200" dirty="0"/>
+              <a:t>This slide: push transition entering from the left</a:t>
             </a:r>
           </a:p>
         </p:txBody>
@@ -16239,7 +16020,13 @@
           <a:lstStyle/>
           <a:p>
             <a:pPr algn="ctr"/>
-            <a:endParaRPr/>
+            <a:endParaRPr>
+              <a:solidFill>
+                <a:schemeClr val="bg1">
+                  <a:lumMod val="50000"/>
+                </a:schemeClr>
+              </a:solidFill>
+            </a:endParaRPr>
           </a:p>
         </p:txBody>
       </p:sp>
@@ -16252,7 +16039,7 @@
         <p:spPr>
           <a:xfrm>
             <a:off x="1508760" y="1645920"/>
-            <a:ext cx="6126480" cy="457200"/>
+            <a:ext cx="1773884" cy="369332"/>
           </a:xfrm>
           <a:prstGeom prst="rect">
             <a:avLst/>
@@ -16265,14 +16052,15 @@
           </a:bodyPr>
           <a:lstStyle/>
           <a:p>
-            <a:pPr algn="ctr"/>
-            <a:r>
-              <a:rPr sz="2800" b="1">
+            <a:r>
+              <a:rPr lang="en-US">
                 <a:solidFill>
-                  <a:srgbClr val="E8651A"/>
+                  <a:schemeClr val="bg1">
+                    <a:lumMod val="50000"/>
+                  </a:schemeClr>
                 </a:solidFill>
               </a:rPr>
-              <a:t>← push 从左推入</a:t>
+              <a:t>← push from left</a:t>
             </a:r>
           </a:p>
         </p:txBody>
@@ -16299,36 +16087,39 @@
           </a:bodyPr>
           <a:lstStyle/>
           <a:p>
-            <a:pPr algn="ctr"/>
-            <a:r>
-              <a:rPr sz="1300">
+            <a:r>
+              <a:rPr lang="en-US">
                 <a:solidFill>
-                  <a:srgbClr val="7F8C8D"/>
+                  <a:schemeClr val="bg1">
+                    <a:lumMod val="50000"/>
+                  </a:schemeClr>
                 </a:solidFill>
               </a:rPr>
-              <a:t>过渡类型: push</a:t>
-            </a:r>
-          </a:p>
-          <a:p>
-            <a:pPr algn="ctr"/>
-            <a:r>
-              <a:rPr sz="1300">
+              <a:t>Transition type: push</a:t>
+            </a:r>
+          </a:p>
+          <a:p>
+            <a:r>
+              <a:rPr lang="en-US">
                 <a:solidFill>
-                  <a:srgbClr val="7F8C8D"/>
+                  <a:schemeClr val="bg1">
+                    <a:lumMod val="50000"/>
+                  </a:schemeClr>
                 </a:solidFill>
               </a:rPr>
-              <a:t>方向: dir="l"（从左）</a:t>
-            </a:r>
-          </a:p>
-          <a:p>
-            <a:pPr algn="ctr"/>
-            <a:r>
-              <a:rPr sz="1300">
+              <a:t>Direction: dir="l" (from left)</a:t>
+            </a:r>
+          </a:p>
+          <a:p>
+            <a:r>
+              <a:rPr lang="en-US">
                 <a:solidFill>
-                  <a:srgbClr val="7F8C8D"/>
+                  <a:schemeClr val="bg1">
+                    <a:lumMod val="50000"/>
+                  </a:schemeClr>
                 </a:solidFill>
               </a:rPr>
-              <a:t>过渡速度: slow</a:t>
+              <a:t>Transition speed: slow</a:t>
             </a:r>
           </a:p>
         </p:txBody>
@@ -16371,50 +16162,6 @@
       </p:grpSpPr>
       <p:sp>
         <p:nvSpPr>
-          <p:cNvPr id="2" name="Rectangle 1"/>
-          <p:cNvSpPr/>
-          <p:nvPr/>
-        </p:nvSpPr>
-        <p:spPr>
-          <a:xfrm>
-            <a:off x="0" y="0"/>
-            <a:ext cx="9144000" cy="54864"/>
-          </a:xfrm>
-          <a:prstGeom prst="rect">
-            <a:avLst/>
-          </a:prstGeom>
-          <a:solidFill>
-            <a:srgbClr val="E8651A"/>
-          </a:solidFill>
-          <a:ln>
-            <a:noFill/>
-          </a:ln>
-        </p:spPr>
-        <p:style>
-          <a:lnRef idx="1">
-            <a:schemeClr val="accent1"/>
-          </a:lnRef>
-          <a:fillRef idx="3">
-            <a:schemeClr val="accent1"/>
-          </a:fillRef>
-          <a:effectRef idx="2">
-            <a:schemeClr val="accent1"/>
-          </a:effectRef>
-          <a:fontRef idx="minor">
-            <a:schemeClr val="lt1"/>
-          </a:fontRef>
-        </p:style>
-        <p:txBody>
-          <a:bodyPr rtlCol="0" anchor="ctr"/>
-          <a:lstStyle/>
-          <a:p>
-            <a:pPr algn="ctr"/>
-            <a:endParaRPr/>
-          </a:p>
-        </p:txBody>
-      </p:sp>
-      <p:sp>
-        <p:nvSpPr>
           <p:cNvPr id="3" name="Oval 2"/>
           <p:cNvSpPr/>
           <p:nvPr/>
@@ -16486,14 +16233,9 @@
           </a:bodyPr>
           <a:lstStyle/>
           <a:p>
-            <a:pPr algn="l"/>
-            <a:r>
-              <a:rPr sz="2600" b="1">
-                <a:solidFill>
-                  <a:srgbClr val="2D3436"/>
-                </a:solidFill>
-              </a:rPr>
-              <a:t>非矩形图片裁剪</a:t>
+            <a:r>
+              <a:rPr lang="en-US"/>
+              <a:t>Non-Rectangular Image Cropping</a:t>
             </a:r>
           </a:p>
         </p:txBody>
@@ -16507,7 +16249,7 @@
         <p:spPr>
           <a:xfrm>
             <a:off x="1051560" y="658368"/>
-            <a:ext cx="7315200" cy="292608"/>
+            <a:ext cx="2744021" cy="276999"/>
           </a:xfrm>
           <a:prstGeom prst="rect">
             <a:avLst/>
@@ -16521,12 +16263,16 @@
           <a:lstStyle/>
           <a:p>
             <a:r>
-              <a:rPr sz="1100" i="1">
-                <a:solidFill>
-                  <a:srgbClr val="7F8C8D"/>
-                </a:solidFill>
-              </a:rPr>
-              <a:t>验证 clip.shape → CSS clip-path 映射</a:t>
+              <a:rPr lang="en-US" sz="1200" dirty="0"/>
+              <a:t>Tests </a:t>
+            </a:r>
+            <a:r>
+              <a:rPr lang="en-US" sz="1200" dirty="0" err="1"/>
+              <a:t>clip.shape</a:t>
+            </a:r>
+            <a:r>
+              <a:rPr lang="en-US" sz="1200" dirty="0"/>
+              <a:t> to CSS clip-path mapping</a:t>
             </a:r>
           </a:p>
         </p:txBody>
@@ -16612,8 +16358,8 @@
         </p:nvSpPr>
         <p:spPr>
           <a:xfrm>
-            <a:off x="411480" y="3136391"/>
-            <a:ext cx="1874519" cy="320040"/>
+            <a:off x="958024" y="3136391"/>
+            <a:ext cx="781431" cy="369332"/>
           </a:xfrm>
           <a:prstGeom prst="rect">
             <a:avLst/>
@@ -16628,13 +16374,8 @@
           <a:p>
             <a:pPr algn="ctr"/>
             <a:r>
-              <a:rPr sz="900" b="1">
-                <a:solidFill>
-                  <a:srgbClr val="2D3436"/>
-                </a:solidFill>
-              </a:rPr>
-              <a:t>椭圆
-(ellipse)</a:t>
+              <a:rPr lang="en-US" dirty="0"/>
+              <a:t>Ellipse</a:t>
             </a:r>
           </a:p>
         </p:txBody>
@@ -16676,8 +16417,8 @@
         </p:nvSpPr>
         <p:spPr>
           <a:xfrm>
-            <a:off x="2560320" y="3136391"/>
-            <a:ext cx="1874519" cy="320040"/>
+            <a:off x="2895876" y="3136391"/>
+            <a:ext cx="1203406" cy="369332"/>
           </a:xfrm>
           <a:prstGeom prst="rect">
             <a:avLst/>
@@ -16692,13 +16433,8 @@
           <a:p>
             <a:pPr algn="ctr"/>
             <a:r>
-              <a:rPr sz="900" b="1">
-                <a:solidFill>
-                  <a:srgbClr val="2D3436"/>
-                </a:solidFill>
-              </a:rPr>
-              <a:t>圆角矩形
-(roundRect)</a:t>
+              <a:rPr lang="en-US"/>
+              <a:t>RoundRect</a:t>
             </a:r>
           </a:p>
         </p:txBody>
@@ -16740,8 +16476,8 @@
         </p:nvSpPr>
         <p:spPr>
           <a:xfrm>
-            <a:off x="4709160" y="3136391"/>
-            <a:ext cx="1874519" cy="320040"/>
+            <a:off x="5126084" y="3136391"/>
+            <a:ext cx="1040670" cy="369332"/>
           </a:xfrm>
           <a:prstGeom prst="rect">
             <a:avLst/>
@@ -16756,13 +16492,8 @@
           <a:p>
             <a:pPr algn="ctr"/>
             <a:r>
-              <a:rPr sz="900" b="1">
-                <a:solidFill>
-                  <a:srgbClr val="2D3436"/>
-                </a:solidFill>
-              </a:rPr>
-              <a:t>菱形
-(diamond)</a:t>
+              <a:rPr lang="en-US"/>
+              <a:t>Diamond</a:t>
             </a:r>
           </a:p>
         </p:txBody>
@@ -16804,8 +16535,8 @@
         </p:nvSpPr>
         <p:spPr>
           <a:xfrm>
-            <a:off x="6858000" y="3136391"/>
-            <a:ext cx="1874519" cy="320040"/>
+            <a:off x="7332568" y="3136391"/>
+            <a:ext cx="925382" cy="369332"/>
           </a:xfrm>
           <a:prstGeom prst="rect">
             <a:avLst/>
@@ -16820,13 +16551,8 @@
           <a:p>
             <a:pPr algn="ctr"/>
             <a:r>
-              <a:rPr sz="900" b="1">
-                <a:solidFill>
-                  <a:srgbClr val="2D3436"/>
-                </a:solidFill>
-              </a:rPr>
-              <a:t>三角形
-(triangle)</a:t>
+              <a:rPr lang="en-US"/>
+              <a:t>Triangle</a:t>
             </a:r>
           </a:p>
         </p:txBody>
@@ -16840,7 +16566,7 @@
         <p:spPr>
           <a:xfrm>
             <a:off x="411480" y="3657600"/>
-            <a:ext cx="8321040" cy="914400"/>
+            <a:ext cx="8321040" cy="646331"/>
           </a:xfrm>
           <a:prstGeom prst="rect">
             <a:avLst/>
@@ -16854,32 +16580,44 @@
           <a:lstStyle/>
           <a:p>
             <a:r>
-              <a:rPr sz="900">
-                <a:solidFill>
-                  <a:srgbClr val="7F8C8D"/>
-                </a:solidFill>
-              </a:rPr>
-              <a:t>💡 上方 4 种形状裁剪使用不同的 prstGeom 预设:</a:t>
-            </a:r>
-          </a:p>
-          <a:p>
-            <a:r>
-              <a:rPr sz="900">
-                <a:solidFill>
-                  <a:srgbClr val="7F8C8D"/>
-                </a:solidFill>
-              </a:rPr>
-              <a:t>ellipse → clip-path: ellipse() | roundRect → border-radius | diamond → clip-path: polygon() | triangle → clip-path: polygon()</a:t>
-            </a:r>
-          </a:p>
-          <a:p>
-            <a:r>
-              <a:rPr sz="900" b="1">
-                <a:solidFill>
-                  <a:srgbClr val="E8651A"/>
-                </a:solidFill>
-              </a:rPr>
-              <a:t>当 clip.shape 功能实现后，图片应被裁剪为对应形状而非默认矩形</a:t>
+              <a:rPr lang="en-US" sz="1200" dirty="0"/>
+              <a:t>💡 The four image crops above use different </a:t>
+            </a:r>
+            <a:r>
+              <a:rPr lang="en-US" sz="1200" dirty="0" err="1"/>
+              <a:t>prstGeom</a:t>
+            </a:r>
+            <a:r>
+              <a:rPr lang="en-US" sz="1200" dirty="0"/>
+              <a:t> presets:</a:t>
+            </a:r>
+          </a:p>
+          <a:p>
+            <a:r>
+              <a:rPr lang="en-US" sz="1200" dirty="0"/>
+              <a:t>ellipse → clip-path: ellipse() | </a:t>
+            </a:r>
+            <a:r>
+              <a:rPr lang="en-US" sz="1200" dirty="0" err="1"/>
+              <a:t>roundRect</a:t>
+            </a:r>
+            <a:r>
+              <a:rPr lang="en-US" sz="1200" dirty="0"/>
+              <a:t> → border-radius | diamond → clip-path: polygon() | triangle → clip-path: polygon()</a:t>
+            </a:r>
+          </a:p>
+          <a:p>
+            <a:r>
+              <a:rPr lang="en-US" sz="1200" dirty="0"/>
+              <a:t>When </a:t>
+            </a:r>
+            <a:r>
+              <a:rPr lang="en-US" sz="1200" dirty="0" err="1"/>
+              <a:t>clip.shape</a:t>
+            </a:r>
+            <a:r>
+              <a:rPr lang="en-US" sz="1200" dirty="0"/>
+              <a:t> is supported, each image should render in its target shape instead of the default rectangle.</a:t>
             </a:r>
           </a:p>
         </p:txBody>
@@ -20742,50 +20480,6 @@
       </p:grpSpPr>
       <p:sp>
         <p:nvSpPr>
-          <p:cNvPr id="2" name="Rectangle 1"/>
-          <p:cNvSpPr/>
-          <p:nvPr/>
-        </p:nvSpPr>
-        <p:spPr>
-          <a:xfrm>
-            <a:off x="0" y="0"/>
-            <a:ext cx="9144000" cy="54864"/>
-          </a:xfrm>
-          <a:prstGeom prst="rect">
-            <a:avLst/>
-          </a:prstGeom>
-          <a:solidFill>
-            <a:srgbClr val="E8651A"/>
-          </a:solidFill>
-          <a:ln>
-            <a:noFill/>
-          </a:ln>
-        </p:spPr>
-        <p:style>
-          <a:lnRef idx="1">
-            <a:schemeClr val="accent1"/>
-          </a:lnRef>
-          <a:fillRef idx="3">
-            <a:schemeClr val="accent1"/>
-          </a:fillRef>
-          <a:effectRef idx="2">
-            <a:schemeClr val="accent1"/>
-          </a:effectRef>
-          <a:fontRef idx="minor">
-            <a:schemeClr val="lt1"/>
-          </a:fontRef>
-        </p:style>
-        <p:txBody>
-          <a:bodyPr rtlCol="0" anchor="ctr"/>
-          <a:lstStyle/>
-          <a:p>
-            <a:pPr algn="ctr"/>
-            <a:endParaRPr/>
-          </a:p>
-        </p:txBody>
-      </p:sp>
-      <p:sp>
-        <p:nvSpPr>
           <p:cNvPr id="3" name="Oval 2"/>
           <p:cNvSpPr/>
           <p:nvPr/>
@@ -20857,14 +20551,9 @@
           </a:bodyPr>
           <a:lstStyle/>
           <a:p>
-            <a:pPr algn="l"/>
-            <a:r>
-              <a:rPr sz="2600" b="1">
-                <a:solidFill>
-                  <a:srgbClr val="2D3436"/>
-                </a:solidFill>
-              </a:rPr>
-              <a:t>表格单元格样式</a:t>
+            <a:r>
+              <a:rPr lang="en-US"/>
+              <a:t>Table Cell Styles</a:t>
             </a:r>
           </a:p>
         </p:txBody>
@@ -20892,12 +20581,8 @@
           <a:lstStyle/>
           <a:p>
             <a:r>
-              <a:rPr sz="1100" i="1">
-                <a:solidFill>
-                  <a:srgbClr val="7F8C8D"/>
-                </a:solidFill>
-              </a:rPr>
-              <a:t>italic / underline / strikethrough / bold / color 组合验证</a:t>
+              <a:rPr lang="en-US"/>
+              <a:t>Validation for italic / underline / strikethrough / bold / color combinations</a:t>
             </a:r>
           </a:p>
         </p:txBody>
@@ -21013,13 +20698,8 @@
                             <a:srgbClr val="FFFFFF"/>
                           </a:solidFill>
                         </a:rPr>
-                        <a:t>样式</a:t>
+                        <a:t>Style</a:t>
                       </a:r>
-                      <a:endParaRPr sz="1100" b="1" dirty="0">
-                        <a:solidFill>
-                          <a:srgbClr val="FFFFFF"/>
-                        </a:solidFill>
-                      </a:endParaRPr>
                     </a:p>
                   </a:txBody>
                   <a:tcPr anchor="ctr">
@@ -21040,34 +20720,7 @@
                             <a:srgbClr val="FFFFFF"/>
                           </a:solidFill>
                         </a:rPr>
-                        <a:t>示例文本</a:t>
-                      </a:r>
-                      <a:endParaRPr sz="1100" b="1" dirty="0">
-                        <a:solidFill>
-                          <a:srgbClr val="FFFFFF"/>
-                        </a:solidFill>
-                      </a:endParaRPr>
-                    </a:p>
-                  </a:txBody>
-                  <a:tcPr anchor="ctr">
-                    <a:solidFill>
-                      <a:srgbClr val="E8651A"/>
-                    </a:solidFill>
-                  </a:tcPr>
-                </a:tc>
-                <a:tc>
-                  <a:txBody>
-                    <a:bodyPr/>
-                    <a:lstStyle/>
-                    <a:p>
-                      <a:pPr algn="ctr"/>
-                      <a:r>
-                        <a:rPr sz="1100" b="1">
-                          <a:solidFill>
-                            <a:srgbClr val="FFFFFF"/>
-                          </a:solidFill>
-                        </a:rPr>
-                        <a:t>组合样式</a:t>
+                        <a:t>Sample Text</a:t>
                       </a:r>
                     </a:p>
                   </a:txBody>
@@ -21089,7 +20742,29 @@
                             <a:srgbClr val="FFFFFF"/>
                           </a:solidFill>
                         </a:rPr>
-                        <a:t>预期效果</a:t>
+                        <a:t>Combined Style</a:t>
+                      </a:r>
+                    </a:p>
+                  </a:txBody>
+                  <a:tcPr anchor="ctr">
+                    <a:solidFill>
+                      <a:srgbClr val="E8651A"/>
+                    </a:solidFill>
+                  </a:tcPr>
+                </a:tc>
+                <a:tc>
+                  <a:txBody>
+                    <a:bodyPr/>
+                    <a:lstStyle/>
+                    <a:p>
+                      <a:pPr algn="ctr"/>
+                      <a:r>
+                        <a:rPr sz="1100" b="1">
+                          <a:solidFill>
+                            <a:srgbClr val="FFFFFF"/>
+                          </a:solidFill>
+                        </a:rPr>
+                        <a:t>Expected Result</a:t>
                       </a:r>
                     </a:p>
                   </a:txBody>
@@ -21118,21 +20793,8 @@
                             <a:srgbClr val="2D3436"/>
                           </a:solidFill>
                         </a:rPr>
-                        <a:t>Italic </a:t>
+                        <a:t>Italic</a:t>
                       </a:r>
-                      <a:r>
-                        <a:rPr sz="1000" b="1" dirty="0" err="1">
-                          <a:solidFill>
-                            <a:srgbClr val="2D3436"/>
-                          </a:solidFill>
-                        </a:rPr>
-                        <a:t>斜体</a:t>
-                      </a:r>
-                      <a:endParaRPr sz="1000" b="1" dirty="0">
-                        <a:solidFill>
-                          <a:srgbClr val="2D3436"/>
-                        </a:solidFill>
-                      </a:endParaRPr>
                     </a:p>
                   </a:txBody>
                   <a:tcPr anchor="ctr"/>
@@ -21162,7 +20824,7 @@
                             <a:srgbClr val="7F8C8D"/>
                           </a:solidFill>
                         </a:rPr>
-                        <a:t>斜体+粗体</a:t>
+                        <a:t>Italic + Bold</a:t>
                       </a:r>
                     </a:p>
                   </a:txBody>
@@ -21200,21 +20862,8 @@
                             <a:srgbClr val="2D3436"/>
                           </a:solidFill>
                         </a:rPr>
-                        <a:t>Underline </a:t>
+                        <a:t>Underline</a:t>
                       </a:r>
-                      <a:r>
-                        <a:rPr sz="1000" b="1" dirty="0" err="1">
-                          <a:solidFill>
-                            <a:srgbClr val="2D3436"/>
-                          </a:solidFill>
-                        </a:rPr>
-                        <a:t>下划线</a:t>
-                      </a:r>
-                      <a:endParaRPr sz="1000" b="1" dirty="0">
-                        <a:solidFill>
-                          <a:srgbClr val="2D3436"/>
-                        </a:solidFill>
-                      </a:endParaRPr>
                     </a:p>
                   </a:txBody>
                   <a:tcPr anchor="ctr">
@@ -21252,7 +20901,7 @@
                             <a:srgbClr val="7F8C8D"/>
                           </a:solidFill>
                         </a:rPr>
-                        <a:t>下划线+橙色</a:t>
+                        <a:t>Underline + Orange</a:t>
                       </a:r>
                     </a:p>
                   </a:txBody>
@@ -21302,7 +20951,7 @@
                             <a:srgbClr val="2D3436"/>
                           </a:solidFill>
                         </a:rPr>
-                        <a:t>Strike 删除线</a:t>
+                        <a:t>Strikethrough</a:t>
                       </a:r>
                     </a:p>
                   </a:txBody>
@@ -21333,13 +20982,8 @@
                             <a:srgbClr val="7F8C8D"/>
                           </a:solidFill>
                         </a:rPr>
-                        <a:t>删除线+斜体</a:t>
+                        <a:t>Strike + Italic</a:t>
                       </a:r>
-                      <a:endParaRPr sz="1000" dirty="0">
-                        <a:solidFill>
-                          <a:srgbClr val="7F8C8D"/>
-                        </a:solidFill>
-                      </a:endParaRPr>
                     </a:p>
                   </a:txBody>
                   <a:tcPr anchor="ctr"/>
@@ -21376,13 +21020,8 @@
                             <a:srgbClr val="2D3436"/>
                           </a:solidFill>
                         </a:rPr>
-                        <a:t>Bold+Color</a:t>
+                        <a:t>Bold + Color</a:t>
                       </a:r>
-                      <a:endParaRPr sz="1000" b="1" dirty="0">
-                        <a:solidFill>
-                          <a:srgbClr val="2D3436"/>
-                        </a:solidFill>
-                      </a:endParaRPr>
                     </a:p>
                   </a:txBody>
                   <a:tcPr anchor="ctr">
@@ -21424,13 +21063,8 @@
                             <a:srgbClr val="7F8C8D"/>
                           </a:solidFill>
                         </a:rPr>
-                        <a:t>全组合</a:t>
+                        <a:t>Full Combination</a:t>
                       </a:r>
-                      <a:endParaRPr sz="1000" dirty="0">
-                        <a:solidFill>
-                          <a:srgbClr val="7F8C8D"/>
-                        </a:solidFill>
-                      </a:endParaRPr>
                     </a:p>
                   </a:txBody>
                   <a:tcPr anchor="ctr">
@@ -21475,7 +21109,7 @@
                             <a:srgbClr val="2D3436"/>
                           </a:solidFill>
                         </a:rPr>
-                        <a:t>Normal 正常</a:t>
+                        <a:t>Normal</a:t>
                       </a:r>
                     </a:p>
                   </a:txBody>
@@ -21506,7 +21140,7 @@
                             <a:srgbClr val="7F8C8D"/>
                           </a:solidFill>
                         </a:rPr>
-                        <a:t>仅颜色</a:t>
+                        <a:t>Color Only</a:t>
                       </a:r>
                     </a:p>
                   </a:txBody>
@@ -21574,50 +21208,6 @@
       </p:grpSpPr>
       <p:sp>
         <p:nvSpPr>
-          <p:cNvPr id="2" name="Rectangle 1"/>
-          <p:cNvSpPr/>
-          <p:nvPr/>
-        </p:nvSpPr>
-        <p:spPr>
-          <a:xfrm>
-            <a:off x="0" y="0"/>
-            <a:ext cx="9144000" cy="54864"/>
-          </a:xfrm>
-          <a:prstGeom prst="rect">
-            <a:avLst/>
-          </a:prstGeom>
-          <a:solidFill>
-            <a:srgbClr val="E8651A"/>
-          </a:solidFill>
-          <a:ln>
-            <a:noFill/>
-          </a:ln>
-        </p:spPr>
-        <p:style>
-          <a:lnRef idx="1">
-            <a:schemeClr val="accent1"/>
-          </a:lnRef>
-          <a:fillRef idx="3">
-            <a:schemeClr val="accent1"/>
-          </a:fillRef>
-          <a:effectRef idx="2">
-            <a:schemeClr val="accent1"/>
-          </a:effectRef>
-          <a:fontRef idx="minor">
-            <a:schemeClr val="lt1"/>
-          </a:fontRef>
-        </p:style>
-        <p:txBody>
-          <a:bodyPr rtlCol="0" anchor="ctr"/>
-          <a:lstStyle/>
-          <a:p>
-            <a:pPr algn="ctr"/>
-            <a:endParaRPr/>
-          </a:p>
-        </p:txBody>
-      </p:sp>
-      <p:sp>
-        <p:nvSpPr>
           <p:cNvPr id="3" name="Oval 2"/>
           <p:cNvSpPr/>
           <p:nvPr/>
@@ -21689,14 +21279,9 @@
           </a:bodyPr>
           <a:lstStyle/>
           <a:p>
-            <a:pPr algn="l"/>
-            <a:r>
-              <a:rPr sz="2600" b="1">
-                <a:solidFill>
-                  <a:srgbClr val="2D3436"/>
-                </a:solidFill>
-              </a:rPr>
-              <a:t>页脚 / 页码 / 日期</a:t>
+            <a:r>
+              <a:rPr lang="en-US"/>
+              <a:t>Footer / Slide Number / Date</a:t>
             </a:r>
           </a:p>
         </p:txBody>
@@ -21710,7 +21295,7 @@
         <p:spPr>
           <a:xfrm>
             <a:off x="1051560" y="658368"/>
-            <a:ext cx="7315200" cy="292608"/>
+            <a:ext cx="4458465" cy="307777"/>
           </a:xfrm>
           <a:prstGeom prst="rect">
             <a:avLst/>
@@ -21724,12 +21309,24 @@
           <a:lstStyle/>
           <a:p>
             <a:r>
-              <a:rPr sz="1100" i="1">
-                <a:solidFill>
-                  <a:srgbClr val="7F8C8D"/>
-                </a:solidFill>
-              </a:rPr>
-              <a:t>验证 hf 占位符自动填充 (ftr / sldNum / dt)</a:t>
+              <a:rPr lang="en-US" sz="1400" dirty="0"/>
+              <a:t>Tests automatic filling of hf placeholders (</a:t>
+            </a:r>
+            <a:r>
+              <a:rPr lang="en-US" sz="1400" dirty="0" err="1"/>
+              <a:t>ftr</a:t>
+            </a:r>
+            <a:r>
+              <a:rPr lang="en-US" sz="1400" dirty="0"/>
+              <a:t> / </a:t>
+            </a:r>
+            <a:r>
+              <a:rPr lang="en-US" sz="1400" dirty="0" err="1"/>
+              <a:t>sldNum</a:t>
+            </a:r>
+            <a:r>
+              <a:rPr lang="en-US" sz="1400" dirty="0"/>
+              <a:t> / dt)</a:t>
             </a:r>
           </a:p>
         </p:txBody>
@@ -21880,7 +21477,7 @@
         <p:spPr>
           <a:xfrm>
             <a:off x="548640" y="2057400"/>
-            <a:ext cx="2331720" cy="274320"/>
+            <a:ext cx="991425" cy="307777"/>
           </a:xfrm>
           <a:prstGeom prst="rect">
             <a:avLst/>
@@ -21893,14 +21490,9 @@
           </a:bodyPr>
           <a:lstStyle/>
           <a:p>
-            <a:pPr algn="ctr"/>
-            <a:r>
-              <a:rPr sz="1200" b="1">
-                <a:solidFill>
-                  <a:srgbClr val="2D3436"/>
-                </a:solidFill>
-              </a:rPr>
-              <a:t>页脚 (ftr)</a:t>
+            <a:r>
+              <a:rPr lang="en-US" sz="1400"/>
+              <a:t>Footer (ftr)</a:t>
             </a:r>
           </a:p>
         </p:txBody>
@@ -21913,8 +21505,8 @@
         </p:nvSpPr>
         <p:spPr>
           <a:xfrm>
-            <a:off x="548640" y="2331720"/>
-            <a:ext cx="2331720" cy="274320"/>
+            <a:off x="961858" y="2331720"/>
+            <a:ext cx="1505284" cy="307777"/>
           </a:xfrm>
           <a:prstGeom prst="rect">
             <a:avLst/>
@@ -21929,7 +21521,7 @@
           <a:p>
             <a:pPr algn="ctr"/>
             <a:r>
-              <a:rPr sz="1600" b="1">
+              <a:rPr sz="1400" b="1">
                 <a:solidFill>
                   <a:srgbClr val="E8651A"/>
                 </a:solidFill>
@@ -21948,7 +21540,7 @@
         <p:spPr>
           <a:xfrm>
             <a:off x="548640" y="2651760"/>
-            <a:ext cx="2331720" cy="411480"/>
+            <a:ext cx="2331720" cy="307777"/>
           </a:xfrm>
           <a:prstGeom prst="rect">
             <a:avLst/>
@@ -21961,14 +21553,9 @@
           </a:bodyPr>
           <a:lstStyle/>
           <a:p>
-            <a:pPr algn="ctr"/>
-            <a:r>
-              <a:rPr sz="800">
-                <a:solidFill>
-                  <a:srgbClr val="7F8C8D"/>
-                </a:solidFill>
-              </a:rPr>
-              <a:t>应在幻灯片底部中央显示自定义页脚文本</a:t>
+            <a:r>
+              <a:rPr lang="en-US" sz="1400" dirty="0"/>
+              <a:t>Footer text appears below</a:t>
             </a:r>
           </a:p>
         </p:txBody>
@@ -22075,7 +21662,7 @@
         <p:spPr>
           <a:xfrm>
             <a:off x="3383280" y="2057400"/>
-            <a:ext cx="2331720" cy="274320"/>
+            <a:ext cx="1882247" cy="307777"/>
           </a:xfrm>
           <a:prstGeom prst="rect">
             <a:avLst/>
@@ -22088,14 +21675,9 @@
           </a:bodyPr>
           <a:lstStyle/>
           <a:p>
-            <a:pPr algn="ctr"/>
-            <a:r>
-              <a:rPr sz="1200" b="1">
-                <a:solidFill>
-                  <a:srgbClr val="2D3436"/>
-                </a:solidFill>
-              </a:rPr>
-              <a:t>页码 (sldNum)</a:t>
+            <a:r>
+              <a:rPr lang="en-US" sz="1400"/>
+              <a:t>Slide Number (sldNum)</a:t>
             </a:r>
           </a:p>
         </p:txBody>
@@ -22108,8 +21690,8 @@
         </p:nvSpPr>
         <p:spPr>
           <a:xfrm>
-            <a:off x="3383280" y="2331720"/>
-            <a:ext cx="2331720" cy="274320"/>
+            <a:off x="4322155" y="2331720"/>
+            <a:ext cx="453970" cy="307777"/>
           </a:xfrm>
           <a:prstGeom prst="rect">
             <a:avLst/>
@@ -22124,7 +21706,7 @@
           <a:p>
             <a:pPr algn="ctr"/>
             <a:r>
-              <a:rPr sz="1600" b="1">
+              <a:rPr sz="1400" b="1">
                 <a:solidFill>
                   <a:srgbClr val="E8651A"/>
                 </a:solidFill>
@@ -22143,7 +21725,7 @@
         <p:spPr>
           <a:xfrm>
             <a:off x="3383280" y="2651760"/>
-            <a:ext cx="2331720" cy="411480"/>
+            <a:ext cx="2331720" cy="307777"/>
           </a:xfrm>
           <a:prstGeom prst="rect">
             <a:avLst/>
@@ -22156,14 +21738,9 @@
           </a:bodyPr>
           <a:lstStyle/>
           <a:p>
-            <a:pPr algn="ctr"/>
-            <a:r>
-              <a:rPr sz="800">
-                <a:solidFill>
-                  <a:srgbClr val="7F8C8D"/>
-                </a:solidFill>
-              </a:rPr>
-              <a:t>应显示当前幻灯片编号，如本页为第 8 页</a:t>
+            <a:r>
+              <a:rPr lang="en-US" sz="1400"/>
+              <a:t>Current slide number</a:t>
             </a:r>
           </a:p>
         </p:txBody>
@@ -22270,7 +21847,7 @@
         <p:spPr>
           <a:xfrm>
             <a:off x="6217920" y="2057400"/>
-            <a:ext cx="2331720" cy="274320"/>
+            <a:ext cx="833498" cy="307777"/>
           </a:xfrm>
           <a:prstGeom prst="rect">
             <a:avLst/>
@@ -22283,14 +21860,9 @@
           </a:bodyPr>
           <a:lstStyle/>
           <a:p>
-            <a:pPr algn="ctr"/>
-            <a:r>
-              <a:rPr sz="1200" b="1">
-                <a:solidFill>
-                  <a:srgbClr val="2D3436"/>
-                </a:solidFill>
-              </a:rPr>
-              <a:t>日期 (dt)</a:t>
+            <a:r>
+              <a:rPr lang="en-US" sz="1400"/>
+              <a:t>Date (dt)</a:t>
             </a:r>
           </a:p>
         </p:txBody>
@@ -22303,8 +21875,8 @@
         </p:nvSpPr>
         <p:spPr>
           <a:xfrm>
-            <a:off x="6217920" y="2331720"/>
-            <a:ext cx="2331720" cy="274320"/>
+            <a:off x="6871460" y="2331720"/>
+            <a:ext cx="1024639" cy="307777"/>
           </a:xfrm>
           <a:prstGeom prst="rect">
             <a:avLst/>
@@ -22319,7 +21891,7 @@
           <a:p>
             <a:pPr algn="ctr"/>
             <a:r>
-              <a:rPr sz="1600" b="1">
+              <a:rPr sz="1400" b="1">
                 <a:solidFill>
                   <a:srgbClr val="E8651A"/>
                 </a:solidFill>
@@ -22338,7 +21910,7 @@
         <p:spPr>
           <a:xfrm>
             <a:off x="6217920" y="2651760"/>
-            <a:ext cx="2331720" cy="411480"/>
+            <a:ext cx="2331720" cy="307777"/>
           </a:xfrm>
           <a:prstGeom prst="rect">
             <a:avLst/>
@@ -22351,14 +21923,9 @@
           </a:bodyPr>
           <a:lstStyle/>
           <a:p>
-            <a:pPr algn="ctr"/>
-            <a:r>
-              <a:rPr sz="800">
-                <a:solidFill>
-                  <a:srgbClr val="7F8C8D"/>
-                </a:solidFill>
-              </a:rPr>
-              <a:t>可设为固定日期或自动更新日期</a:t>
+            <a:r>
+              <a:rPr lang="en-US" sz="1400"/>
+              <a:t>Fixed or auto date</a:t>
             </a:r>
           </a:p>
         </p:txBody>
@@ -22386,12 +21953,16 @@
           <a:lstStyle/>
           <a:p>
             <a:r>
-              <a:rPr sz="1000" i="1">
-                <a:solidFill>
-                  <a:srgbClr val="7F8C8D"/>
-                </a:solidFill>
-              </a:rPr>
-              <a:t>💡 如果占位符为空白，说明 viewer 尚未解析 p:hf 配置并填充值</a:t>
+              <a:rPr lang="en-US" dirty="0"/>
+              <a:t>💡 </a:t>
+            </a:r>
+            <a:r>
+              <a:rPr lang="en-US" dirty="0" err="1"/>
+              <a:t>p:hf</a:t>
+            </a:r>
+            <a:r>
+              <a:rPr lang="en-US" dirty="0"/>
+              <a:t> values parsed.</a:t>
             </a:r>
           </a:p>
         </p:txBody>
@@ -22511,50 +22082,6 @@
           <a:chExt cx="0" cy="0"/>
         </a:xfrm>
       </p:grpSpPr>
-      <p:sp>
-        <p:nvSpPr>
-          <p:cNvPr id="2" name="Rectangle 1"/>
-          <p:cNvSpPr/>
-          <p:nvPr/>
-        </p:nvSpPr>
-        <p:spPr>
-          <a:xfrm>
-            <a:off x="0" y="0"/>
-            <a:ext cx="9144000" cy="54864"/>
-          </a:xfrm>
-          <a:prstGeom prst="rect">
-            <a:avLst/>
-          </a:prstGeom>
-          <a:solidFill>
-            <a:srgbClr val="E8651A"/>
-          </a:solidFill>
-          <a:ln>
-            <a:noFill/>
-          </a:ln>
-        </p:spPr>
-        <p:style>
-          <a:lnRef idx="1">
-            <a:schemeClr val="accent1"/>
-          </a:lnRef>
-          <a:fillRef idx="3">
-            <a:schemeClr val="accent1"/>
-          </a:fillRef>
-          <a:effectRef idx="2">
-            <a:schemeClr val="accent1"/>
-          </a:effectRef>
-          <a:fontRef idx="minor">
-            <a:schemeClr val="lt1"/>
-          </a:fontRef>
-        </p:style>
-        <p:txBody>
-          <a:bodyPr rtlCol="0" anchor="ctr"/>
-          <a:lstStyle/>
-          <a:p>
-            <a:pPr algn="ctr"/>
-            <a:endParaRPr/>
-          </a:p>
-        </p:txBody>
-      </p:sp>
       <p:sp>
         <p:nvSpPr>
           <p:cNvPr id="3" name="Oval 2"/>
@@ -22628,14 +22155,9 @@
           </a:bodyPr>
           <a:lstStyle/>
           <a:p>
-            <a:pPr algn="l"/>
-            <a:r>
-              <a:rPr sz="2600" b="1">
-                <a:solidFill>
-                  <a:srgbClr val="2D3436"/>
-                </a:solidFill>
-              </a:rPr>
-              <a:t>文本框多列布局</a:t>
+            <a:r>
+              <a:rPr lang="en-US"/>
+              <a:t>Multilingual Text Flow / 多语言文本流</a:t>
             </a:r>
           </a:p>
         </p:txBody>
@@ -22649,7 +22171,7 @@
         <p:spPr>
           <a:xfrm>
             <a:off x="1051560" y="658368"/>
-            <a:ext cx="7315200" cy="292608"/>
+            <a:ext cx="4330481" cy="307777"/>
           </a:xfrm>
           <a:prstGeom prst="rect">
             <a:avLst/>
@@ -22663,82 +22185,30 @@
           <a:lstStyle/>
           <a:p>
             <a:r>
-              <a:rPr sz="1100" i="1" dirty="0" err="1">
-                <a:solidFill>
-                  <a:srgbClr val="7F8C8D"/>
-                </a:solidFill>
-              </a:rPr>
-              <a:t>验证</a:t>
-            </a:r>
-            <a:r>
-              <a:rPr sz="1100" i="1" dirty="0">
-                <a:solidFill>
-                  <a:srgbClr val="7F8C8D"/>
-                </a:solidFill>
-              </a:rPr>
+              <a:rPr lang="en-US" sz="1400" dirty="0"/>
+              <a:t>CJK + English mixed layout using </a:t>
+            </a:r>
+            <a:r>
+              <a:rPr lang="en-US" sz="1400" dirty="0" err="1"/>
+              <a:t>bodyPr</a:t>
+            </a:r>
+            <a:r>
+              <a:rPr lang="en-US" sz="1400" dirty="0"/>
               <a:t> </a:t>
             </a:r>
             <a:r>
-              <a:rPr sz="1100" i="1" dirty="0" err="1">
-                <a:solidFill>
-                  <a:srgbClr val="7F8C8D"/>
-                </a:solidFill>
-              </a:rPr>
-              <a:t>bodyPr</a:t>
-            </a:r>
-            <a:r>
-              <a:rPr sz="1100" i="1" dirty="0">
-                <a:solidFill>
-                  <a:srgbClr val="7F8C8D"/>
-                </a:solidFill>
-              </a:rPr>
-              <a:t> </a:t>
-            </a:r>
-            <a:r>
-              <a:rPr sz="1100" i="1" dirty="0" err="1">
-                <a:solidFill>
-                  <a:srgbClr val="7F8C8D"/>
-                </a:solidFill>
-              </a:rPr>
+              <a:rPr lang="en-US" sz="1400" dirty="0" err="1"/>
               <a:t>numCol</a:t>
             </a:r>
             <a:r>
-              <a:rPr sz="1100" i="1" dirty="0">
-                <a:solidFill>
-                  <a:srgbClr val="7F8C8D"/>
-                </a:solidFill>
-              </a:rPr>
+              <a:rPr lang="en-US" sz="1400" dirty="0"/>
               <a:t> + </a:t>
             </a:r>
             <a:r>
-              <a:rPr sz="1100" i="1" dirty="0" err="1">
-                <a:solidFill>
-                  <a:srgbClr val="7F8C8D"/>
-                </a:solidFill>
-              </a:rPr>
+              <a:rPr lang="en-US" sz="1400" dirty="0" err="1"/>
               <a:t>spcCol</a:t>
             </a:r>
-            <a:r>
-              <a:rPr sz="1100" i="1" dirty="0">
-                <a:solidFill>
-                  <a:srgbClr val="7F8C8D"/>
-                </a:solidFill>
-              </a:rPr>
-              <a:t> </a:t>
-            </a:r>
-            <a:r>
-              <a:rPr sz="1100" i="1" dirty="0" err="1">
-                <a:solidFill>
-                  <a:srgbClr val="7F8C8D"/>
-                </a:solidFill>
-              </a:rPr>
-              <a:t>解析</a:t>
-            </a:r>
-            <a:endParaRPr sz="1100" i="1" dirty="0">
-              <a:solidFill>
-                <a:srgbClr val="7F8C8D"/>
-              </a:solidFill>
-            </a:endParaRPr>
+            <a:endParaRPr lang="en-US" sz="1400" dirty="0"/>
           </a:p>
         </p:txBody>
       </p:sp>
@@ -22809,12 +22279,8 @@
           <a:lstStyle/>
           <a:p>
             <a:r>
-              <a:rPr sz="1100" b="1">
-                <a:solidFill>
-                  <a:srgbClr val="E8651A"/>
-                </a:solidFill>
-              </a:rPr>
-              <a:t>● 双栏文本 (numCol=2)</a:t>
+              <a:rPr lang="en-US"/>
+              <a:t>● Two-column text (numCol=2)</a:t>
             </a:r>
           </a:p>
         </p:txBody>
@@ -22827,7 +22293,7 @@
         </p:nvSpPr>
         <p:spPr>
           <a:xfrm>
-            <a:off x="411480" y="1371600"/>
+            <a:off x="411480" y="1431234"/>
             <a:ext cx="8321040" cy="1463040"/>
           </a:xfrm>
           <a:prstGeom prst="rect">
@@ -22873,7 +22339,7 @@
         </p:nvSpPr>
         <p:spPr>
           <a:xfrm>
-            <a:off x="548640" y="1417320"/>
+            <a:off x="548640" y="1496832"/>
             <a:ext cx="8046720" cy="1371600"/>
           </a:xfrm>
           <a:prstGeom prst="rect">
@@ -22888,42 +22354,54 @@
           <a:lstStyle/>
           <a:p>
             <a:r>
-              <a:rPr sz="1000">
-                <a:solidFill>
-                  <a:srgbClr val="2D3436"/>
-                </a:solidFill>
-              </a:rPr>
-              <a:t>这是第一段内容，验证双栏文本布局。在 PowerPoint 中，bodyPr 的 numCol 属性可以指定文本框的列数，文本溢出后自动流入下一列。这是一个非常实用的功能。</a:t>
-            </a:r>
-          </a:p>
-          <a:p>
-            <a:r>
-              <a:rPr sz="1000">
-                <a:solidFill>
-                  <a:srgbClr val="2D3436"/>
-                </a:solidFill>
-              </a:rPr>
-              <a:t>这是第二段内容。如果双栏功能正常，这些文字应该均匀分布在两列中，并且列间有可见的 spcCol 间距分隔。多列布局常用于报纸、杂志风格的排版。</a:t>
-            </a:r>
-          </a:p>
-          <a:p>
-            <a:r>
-              <a:rPr sz="1000">
-                <a:solidFill>
-                  <a:srgbClr val="2D3436"/>
-                </a:solidFill>
-              </a:rPr>
-              <a:t>If this feature works correctly, you should see text split across two columns with a visible gap between them. This paragraph adds more content to ensure the text overflows into the second column properly.</a:t>
-            </a:r>
-          </a:p>
-          <a:p>
-            <a:r>
-              <a:rPr sz="1000">
-                <a:solidFill>
-                  <a:srgbClr val="2D3436"/>
-                </a:solidFill>
-              </a:rPr>
-              <a:t>第四段内容继续填充文本。PowerPoint 的多列布局是基于文本框高度的固定约束来实现的，当第一列文本填满后，后续文本自动流入第二列显示。</a:t>
+              <a:rPr lang="en-US" sz="1600" dirty="0"/>
+              <a:t>English text verifies two-column flow. Overflow should continue in the next column with a visible </a:t>
+            </a:r>
+            <a:r>
+              <a:rPr lang="en-US" sz="1600" dirty="0" err="1"/>
+              <a:t>spcCol</a:t>
+            </a:r>
+            <a:r>
+              <a:rPr lang="en-US" sz="1600" dirty="0"/>
+              <a:t> gap.</a:t>
+            </a:r>
+          </a:p>
+          <a:p>
+            <a:endParaRPr lang="en-US" sz="1600" dirty="0"/>
+          </a:p>
+          <a:p>
+            <a:endParaRPr lang="en-US" sz="1600" dirty="0"/>
+          </a:p>
+          <a:p>
+            <a:r>
+              <a:rPr lang="en-US" sz="1600" dirty="0" err="1"/>
+              <a:t>中文混排：验证</a:t>
+            </a:r>
+            <a:r>
+              <a:rPr lang="en-US" sz="1600" dirty="0"/>
+              <a:t> CJK </a:t>
+            </a:r>
+            <a:r>
+              <a:rPr lang="en-US" sz="1600" dirty="0" err="1"/>
+              <a:t>字体</a:t>
+            </a:r>
+            <a:r>
+              <a:rPr lang="en-US" sz="1600" dirty="0"/>
+              <a:t>。</a:t>
+            </a:r>
+          </a:p>
+          <a:p>
+            <a:r>
+              <a:rPr lang="en-US" sz="1600" dirty="0"/>
+              <a:t>Mixed English + </a:t>
+            </a:r>
+            <a:r>
+              <a:rPr lang="en-US" sz="1600" dirty="0" err="1"/>
+              <a:t>中文</a:t>
+            </a:r>
+            <a:r>
+              <a:rPr lang="en-US" sz="1600" dirty="0"/>
+              <a:t> should wrap without clipping.</a:t>
             </a:r>
           </a:p>
         </p:txBody>
@@ -22951,12 +22429,8 @@
           <a:lstStyle/>
           <a:p>
             <a:r>
-              <a:rPr sz="1100" b="1">
-                <a:solidFill>
-                  <a:srgbClr val="E8651A"/>
-                </a:solidFill>
-              </a:rPr>
-              <a:t>● 三栏文本 (numCol=3)</a:t>
+              <a:rPr lang="en-US"/>
+              <a:t>● Three-column text (numCol=3)</a:t>
             </a:r>
           </a:p>
         </p:txBody>
@@ -22969,7 +22443,7 @@
         </p:nvSpPr>
         <p:spPr>
           <a:xfrm>
-            <a:off x="411480" y="3291840"/>
+            <a:off x="411480" y="3371352"/>
             <a:ext cx="8321040" cy="1554480"/>
           </a:xfrm>
           <a:prstGeom prst="rect">
@@ -23015,7 +22489,7 @@
         </p:nvSpPr>
         <p:spPr>
           <a:xfrm>
-            <a:off x="548640" y="3337560"/>
+            <a:off x="548640" y="3466767"/>
             <a:ext cx="8046720" cy="1051560"/>
           </a:xfrm>
           <a:prstGeom prst="rect">
@@ -23030,892 +22504,34 @@
           <a:lstStyle/>
           <a:p>
             <a:r>
-              <a:rPr sz="900" dirty="0">
-                <a:solidFill>
-                  <a:srgbClr val="2D3436"/>
-                </a:solidFill>
-              </a:rPr>
-              <a:t>Column 1: Lorem ipsum dolor sit </a:t>
-            </a:r>
-            <a:r>
-              <a:rPr sz="900" dirty="0" err="1">
-                <a:solidFill>
-                  <a:srgbClr val="2D3436"/>
-                </a:solidFill>
-              </a:rPr>
-              <a:t>amet</a:t>
-            </a:r>
-            <a:r>
-              <a:rPr sz="900" dirty="0">
-                <a:solidFill>
-                  <a:srgbClr val="2D3436"/>
-                </a:solidFill>
-              </a:rPr>
-              <a:t>, </a:t>
-            </a:r>
-            <a:r>
-              <a:rPr sz="900" dirty="0" err="1">
-                <a:solidFill>
-                  <a:srgbClr val="2D3436"/>
-                </a:solidFill>
-              </a:rPr>
-              <a:t>consectetur</a:t>
-            </a:r>
-            <a:r>
-              <a:rPr sz="900" dirty="0">
-                <a:solidFill>
-                  <a:srgbClr val="2D3436"/>
-                </a:solidFill>
-              </a:rPr>
-              <a:t> </a:t>
-            </a:r>
-            <a:r>
-              <a:rPr sz="900" dirty="0" err="1">
-                <a:solidFill>
-                  <a:srgbClr val="2D3436"/>
-                </a:solidFill>
-              </a:rPr>
-              <a:t>adipiscing</a:t>
-            </a:r>
-            <a:r>
-              <a:rPr sz="900" dirty="0">
-                <a:solidFill>
-                  <a:srgbClr val="2D3436"/>
-                </a:solidFill>
-              </a:rPr>
-              <a:t> </a:t>
-            </a:r>
-            <a:r>
-              <a:rPr sz="900" dirty="0" err="1">
-                <a:solidFill>
-                  <a:srgbClr val="2D3436"/>
-                </a:solidFill>
-              </a:rPr>
-              <a:t>elit</a:t>
-            </a:r>
-            <a:r>
-              <a:rPr sz="900" dirty="0">
-                <a:solidFill>
-                  <a:srgbClr val="2D3436"/>
-                </a:solidFill>
-              </a:rPr>
-              <a:t>. Sed do </a:t>
-            </a:r>
-            <a:r>
-              <a:rPr sz="900" dirty="0" err="1">
-                <a:solidFill>
-                  <a:srgbClr val="2D3436"/>
-                </a:solidFill>
-              </a:rPr>
-              <a:t>eiusmod</a:t>
-            </a:r>
-            <a:r>
-              <a:rPr sz="900" dirty="0">
-                <a:solidFill>
-                  <a:srgbClr val="2D3436"/>
-                </a:solidFill>
-              </a:rPr>
-              <a:t> </a:t>
-            </a:r>
-            <a:r>
-              <a:rPr sz="900" dirty="0" err="1">
-                <a:solidFill>
-                  <a:srgbClr val="2D3436"/>
-                </a:solidFill>
-              </a:rPr>
-              <a:t>tempor</a:t>
-            </a:r>
-            <a:r>
-              <a:rPr sz="900" dirty="0">
-                <a:solidFill>
-                  <a:srgbClr val="2D3436"/>
-                </a:solidFill>
-              </a:rPr>
-              <a:t> </a:t>
-            </a:r>
-            <a:r>
-              <a:rPr sz="900" dirty="0" err="1">
-                <a:solidFill>
-                  <a:srgbClr val="2D3436"/>
-                </a:solidFill>
-              </a:rPr>
-              <a:t>incididunt</a:t>
-            </a:r>
-            <a:r>
-              <a:rPr sz="900" dirty="0">
-                <a:solidFill>
-                  <a:srgbClr val="2D3436"/>
-                </a:solidFill>
-              </a:rPr>
-              <a:t> </a:t>
-            </a:r>
-            <a:r>
-              <a:rPr sz="900" dirty="0" err="1">
-                <a:solidFill>
-                  <a:srgbClr val="2D3436"/>
-                </a:solidFill>
-              </a:rPr>
-              <a:t>ut</a:t>
-            </a:r>
-            <a:r>
-              <a:rPr sz="900" dirty="0">
-                <a:solidFill>
-                  <a:srgbClr val="2D3436"/>
-                </a:solidFill>
-              </a:rPr>
-              <a:t> labore et dolore magna </a:t>
-            </a:r>
-            <a:r>
-              <a:rPr sz="900" dirty="0" err="1">
-                <a:solidFill>
-                  <a:srgbClr val="2D3436"/>
-                </a:solidFill>
-              </a:rPr>
-              <a:t>aliqua</a:t>
-            </a:r>
-            <a:r>
-              <a:rPr sz="900" dirty="0">
-                <a:solidFill>
-                  <a:srgbClr val="2D3436"/>
-                </a:solidFill>
-              </a:rPr>
-              <a:t>. Ut </a:t>
-            </a:r>
-            <a:r>
-              <a:rPr sz="900" dirty="0" err="1">
-                <a:solidFill>
-                  <a:srgbClr val="2D3436"/>
-                </a:solidFill>
-              </a:rPr>
-              <a:t>enim</a:t>
-            </a:r>
-            <a:r>
-              <a:rPr sz="900" dirty="0">
-                <a:solidFill>
-                  <a:srgbClr val="2D3436"/>
-                </a:solidFill>
-              </a:rPr>
-              <a:t> ad minim </a:t>
-            </a:r>
-            <a:r>
-              <a:rPr sz="900" dirty="0" err="1">
-                <a:solidFill>
-                  <a:srgbClr val="2D3436"/>
-                </a:solidFill>
-              </a:rPr>
-              <a:t>veniam</a:t>
-            </a:r>
-            <a:r>
-              <a:rPr sz="900" dirty="0">
-                <a:solidFill>
-                  <a:srgbClr val="2D3436"/>
-                </a:solidFill>
-              </a:rPr>
-              <a:t>, </a:t>
-            </a:r>
-            <a:r>
-              <a:rPr sz="900" dirty="0" err="1">
-                <a:solidFill>
-                  <a:srgbClr val="2D3436"/>
-                </a:solidFill>
-              </a:rPr>
-              <a:t>quis</a:t>
-            </a:r>
-            <a:r>
-              <a:rPr sz="900" dirty="0">
-                <a:solidFill>
-                  <a:srgbClr val="2D3436"/>
-                </a:solidFill>
-              </a:rPr>
-              <a:t> </a:t>
-            </a:r>
-            <a:r>
-              <a:rPr sz="900" dirty="0" err="1">
-                <a:solidFill>
-                  <a:srgbClr val="2D3436"/>
-                </a:solidFill>
-              </a:rPr>
-              <a:t>nostrud</a:t>
-            </a:r>
-            <a:r>
-              <a:rPr sz="900" dirty="0">
-                <a:solidFill>
-                  <a:srgbClr val="2D3436"/>
-                </a:solidFill>
-              </a:rPr>
-              <a:t> exercitation.</a:t>
-            </a:r>
-          </a:p>
-          <a:p>
-            <a:r>
-              <a:rPr sz="900" dirty="0">
-                <a:solidFill>
-                  <a:srgbClr val="2D3436"/>
-                </a:solidFill>
-              </a:rPr>
-              <a:t>Column 2: </a:t>
-            </a:r>
-            <a:r>
-              <a:rPr sz="900" dirty="0" err="1">
-                <a:solidFill>
-                  <a:srgbClr val="2D3436"/>
-                </a:solidFill>
-              </a:rPr>
-              <a:t>Ullamco</a:t>
-            </a:r>
-            <a:r>
-              <a:rPr sz="900" dirty="0">
-                <a:solidFill>
-                  <a:srgbClr val="2D3436"/>
-                </a:solidFill>
-              </a:rPr>
-              <a:t> </a:t>
-            </a:r>
-            <a:r>
-              <a:rPr sz="900" dirty="0" err="1">
-                <a:solidFill>
-                  <a:srgbClr val="2D3436"/>
-                </a:solidFill>
-              </a:rPr>
-              <a:t>laboris</a:t>
-            </a:r>
-            <a:r>
-              <a:rPr sz="900" dirty="0">
-                <a:solidFill>
-                  <a:srgbClr val="2D3436"/>
-                </a:solidFill>
-              </a:rPr>
-              <a:t> nisi </a:t>
-            </a:r>
-            <a:r>
-              <a:rPr sz="900" dirty="0" err="1">
-                <a:solidFill>
-                  <a:srgbClr val="2D3436"/>
-                </a:solidFill>
-              </a:rPr>
-              <a:t>ut</a:t>
-            </a:r>
-            <a:r>
-              <a:rPr sz="900" dirty="0">
-                <a:solidFill>
-                  <a:srgbClr val="2D3436"/>
-                </a:solidFill>
-              </a:rPr>
-              <a:t> </a:t>
-            </a:r>
-            <a:r>
-              <a:rPr sz="900" dirty="0" err="1">
-                <a:solidFill>
-                  <a:srgbClr val="2D3436"/>
-                </a:solidFill>
-              </a:rPr>
-              <a:t>aliquip</a:t>
-            </a:r>
-            <a:r>
-              <a:rPr sz="900" dirty="0">
-                <a:solidFill>
-                  <a:srgbClr val="2D3436"/>
-                </a:solidFill>
-              </a:rPr>
-              <a:t> ex </a:t>
-            </a:r>
-            <a:r>
-              <a:rPr sz="900" dirty="0" err="1">
-                <a:solidFill>
-                  <a:srgbClr val="2D3436"/>
-                </a:solidFill>
-              </a:rPr>
-              <a:t>ea</a:t>
-            </a:r>
-            <a:r>
-              <a:rPr sz="900" dirty="0">
-                <a:solidFill>
-                  <a:srgbClr val="2D3436"/>
-                </a:solidFill>
-              </a:rPr>
-              <a:t> </a:t>
-            </a:r>
-            <a:r>
-              <a:rPr sz="900" dirty="0" err="1">
-                <a:solidFill>
-                  <a:srgbClr val="2D3436"/>
-                </a:solidFill>
-              </a:rPr>
-              <a:t>commodo</a:t>
-            </a:r>
-            <a:r>
-              <a:rPr sz="900" dirty="0">
-                <a:solidFill>
-                  <a:srgbClr val="2D3436"/>
-                </a:solidFill>
-              </a:rPr>
-              <a:t> </a:t>
-            </a:r>
-            <a:r>
-              <a:rPr sz="900" dirty="0" err="1">
-                <a:solidFill>
-                  <a:srgbClr val="2D3436"/>
-                </a:solidFill>
-              </a:rPr>
-              <a:t>consequat</a:t>
-            </a:r>
-            <a:r>
-              <a:rPr sz="900" dirty="0">
-                <a:solidFill>
-                  <a:srgbClr val="2D3436"/>
-                </a:solidFill>
-              </a:rPr>
-              <a:t>. Duis </a:t>
-            </a:r>
-            <a:r>
-              <a:rPr sz="900" dirty="0" err="1">
-                <a:solidFill>
-                  <a:srgbClr val="2D3436"/>
-                </a:solidFill>
-              </a:rPr>
-              <a:t>aute</a:t>
-            </a:r>
-            <a:r>
-              <a:rPr sz="900" dirty="0">
-                <a:solidFill>
-                  <a:srgbClr val="2D3436"/>
-                </a:solidFill>
-              </a:rPr>
-              <a:t> </a:t>
-            </a:r>
-            <a:r>
-              <a:rPr sz="900" dirty="0" err="1">
-                <a:solidFill>
-                  <a:srgbClr val="2D3436"/>
-                </a:solidFill>
-              </a:rPr>
-              <a:t>irure</a:t>
-            </a:r>
-            <a:r>
-              <a:rPr sz="900" dirty="0">
-                <a:solidFill>
-                  <a:srgbClr val="2D3436"/>
-                </a:solidFill>
-              </a:rPr>
-              <a:t> dolor in </a:t>
-            </a:r>
-            <a:r>
-              <a:rPr sz="900" dirty="0" err="1">
-                <a:solidFill>
-                  <a:srgbClr val="2D3436"/>
-                </a:solidFill>
-              </a:rPr>
-              <a:t>reprehenderit</a:t>
-            </a:r>
-            <a:r>
-              <a:rPr sz="900" dirty="0">
-                <a:solidFill>
-                  <a:srgbClr val="2D3436"/>
-                </a:solidFill>
-              </a:rPr>
-              <a:t> in </a:t>
-            </a:r>
-            <a:r>
-              <a:rPr sz="900" dirty="0" err="1">
-                <a:solidFill>
-                  <a:srgbClr val="2D3436"/>
-                </a:solidFill>
-              </a:rPr>
-              <a:t>voluptate</a:t>
-            </a:r>
-            <a:r>
-              <a:rPr sz="900" dirty="0">
-                <a:solidFill>
-                  <a:srgbClr val="2D3436"/>
-                </a:solidFill>
-              </a:rPr>
-              <a:t> </a:t>
-            </a:r>
-            <a:r>
-              <a:rPr sz="900" dirty="0" err="1">
-                <a:solidFill>
-                  <a:srgbClr val="2D3436"/>
-                </a:solidFill>
-              </a:rPr>
-              <a:t>velit</a:t>
-            </a:r>
-            <a:r>
-              <a:rPr sz="900" dirty="0">
-                <a:solidFill>
-                  <a:srgbClr val="2D3436"/>
-                </a:solidFill>
-              </a:rPr>
-              <a:t> </a:t>
-            </a:r>
-            <a:r>
-              <a:rPr sz="900" dirty="0" err="1">
-                <a:solidFill>
-                  <a:srgbClr val="2D3436"/>
-                </a:solidFill>
-              </a:rPr>
-              <a:t>esse</a:t>
-            </a:r>
-            <a:r>
-              <a:rPr sz="900" dirty="0">
-                <a:solidFill>
-                  <a:srgbClr val="2D3436"/>
-                </a:solidFill>
-              </a:rPr>
-              <a:t> </a:t>
-            </a:r>
-            <a:r>
-              <a:rPr sz="900" dirty="0" err="1">
-                <a:solidFill>
-                  <a:srgbClr val="2D3436"/>
-                </a:solidFill>
-              </a:rPr>
-              <a:t>cillum</a:t>
-            </a:r>
-            <a:r>
-              <a:rPr sz="900" dirty="0">
-                <a:solidFill>
-                  <a:srgbClr val="2D3436"/>
-                </a:solidFill>
-              </a:rPr>
-              <a:t> dolore </a:t>
-            </a:r>
-            <a:r>
-              <a:rPr sz="900" dirty="0" err="1">
-                <a:solidFill>
-                  <a:srgbClr val="2D3436"/>
-                </a:solidFill>
-              </a:rPr>
-              <a:t>eu</a:t>
-            </a:r>
-            <a:r>
-              <a:rPr sz="900" dirty="0">
-                <a:solidFill>
-                  <a:srgbClr val="2D3436"/>
-                </a:solidFill>
-              </a:rPr>
-              <a:t> </a:t>
-            </a:r>
-            <a:r>
-              <a:rPr sz="900" dirty="0" err="1">
-                <a:solidFill>
-                  <a:srgbClr val="2D3436"/>
-                </a:solidFill>
-              </a:rPr>
-              <a:t>fugiat</a:t>
-            </a:r>
-            <a:r>
-              <a:rPr sz="900" dirty="0">
-                <a:solidFill>
-                  <a:srgbClr val="2D3436"/>
-                </a:solidFill>
-              </a:rPr>
-              <a:t> </a:t>
-            </a:r>
-            <a:r>
-              <a:rPr sz="900" dirty="0" err="1">
-                <a:solidFill>
-                  <a:srgbClr val="2D3436"/>
-                </a:solidFill>
-              </a:rPr>
-              <a:t>nulla</a:t>
-            </a:r>
-            <a:r>
-              <a:rPr sz="900" dirty="0">
-                <a:solidFill>
-                  <a:srgbClr val="2D3436"/>
-                </a:solidFill>
-              </a:rPr>
-              <a:t> </a:t>
-            </a:r>
-            <a:r>
-              <a:rPr sz="900" dirty="0" err="1">
-                <a:solidFill>
-                  <a:srgbClr val="2D3436"/>
-                </a:solidFill>
-              </a:rPr>
-              <a:t>pariatur</a:t>
-            </a:r>
-            <a:r>
-              <a:rPr sz="900" dirty="0">
-                <a:solidFill>
-                  <a:srgbClr val="2D3436"/>
-                </a:solidFill>
-              </a:rPr>
-              <a:t>.</a:t>
-            </a:r>
-          </a:p>
-          <a:p>
-            <a:r>
-              <a:rPr sz="900" dirty="0">
-                <a:solidFill>
-                  <a:srgbClr val="2D3436"/>
-                </a:solidFill>
-              </a:rPr>
+              <a:rPr lang="en-US" sz="1600" dirty="0"/>
+              <a:t>Column 1: concise English text.</a:t>
+            </a:r>
+          </a:p>
+          <a:p>
+            <a:endParaRPr lang="en-US" sz="1600" dirty="0"/>
+          </a:p>
+          <a:p>
+            <a:r>
+              <a:rPr lang="en-US" sz="1600" dirty="0"/>
+              <a:t>Column 2: renderer keeps column spacing.</a:t>
+            </a:r>
+          </a:p>
+          <a:p>
+            <a:endParaRPr lang="en-US" sz="1600" dirty="0"/>
+          </a:p>
+          <a:p>
+            <a:r>
+              <a:rPr lang="en-US" sz="1600" dirty="0"/>
               <a:t>Column 3: </a:t>
             </a:r>
             <a:r>
-              <a:rPr sz="900" dirty="0" err="1">
-                <a:solidFill>
-                  <a:srgbClr val="2D3436"/>
-                </a:solidFill>
-              </a:rPr>
-              <a:t>Excepteur</a:t>
-            </a:r>
-            <a:r>
-              <a:rPr sz="900" dirty="0">
-                <a:solidFill>
-                  <a:srgbClr val="2D3436"/>
-                </a:solidFill>
-              </a:rPr>
-              <a:t> </a:t>
-            </a:r>
-            <a:r>
-              <a:rPr sz="900" dirty="0" err="1">
-                <a:solidFill>
-                  <a:srgbClr val="2D3436"/>
-                </a:solidFill>
-              </a:rPr>
-              <a:t>sint</a:t>
-            </a:r>
-            <a:r>
-              <a:rPr sz="900" dirty="0">
-                <a:solidFill>
-                  <a:srgbClr val="2D3436"/>
-                </a:solidFill>
-              </a:rPr>
-              <a:t> </a:t>
-            </a:r>
-            <a:r>
-              <a:rPr sz="900" dirty="0" err="1">
-                <a:solidFill>
-                  <a:srgbClr val="2D3436"/>
-                </a:solidFill>
-              </a:rPr>
-              <a:t>occaecat</a:t>
-            </a:r>
-            <a:r>
-              <a:rPr sz="900" dirty="0">
-                <a:solidFill>
-                  <a:srgbClr val="2D3436"/>
-                </a:solidFill>
-              </a:rPr>
-              <a:t> </a:t>
-            </a:r>
-            <a:r>
-              <a:rPr sz="900" dirty="0" err="1">
-                <a:solidFill>
-                  <a:srgbClr val="2D3436"/>
-                </a:solidFill>
-              </a:rPr>
-              <a:t>cupidatat</a:t>
-            </a:r>
-            <a:r>
-              <a:rPr sz="900" dirty="0">
-                <a:solidFill>
-                  <a:srgbClr val="2D3436"/>
-                </a:solidFill>
-              </a:rPr>
-              <a:t> non </a:t>
-            </a:r>
-            <a:r>
-              <a:rPr sz="900" dirty="0" err="1">
-                <a:solidFill>
-                  <a:srgbClr val="2D3436"/>
-                </a:solidFill>
-              </a:rPr>
-              <a:t>proident</a:t>
-            </a:r>
-            <a:r>
-              <a:rPr sz="900" dirty="0">
-                <a:solidFill>
-                  <a:srgbClr val="2D3436"/>
-                </a:solidFill>
-              </a:rPr>
-              <a:t>, sunt in culpa qui </a:t>
-            </a:r>
-            <a:r>
-              <a:rPr sz="900" dirty="0" err="1">
-                <a:solidFill>
-                  <a:srgbClr val="2D3436"/>
-                </a:solidFill>
-              </a:rPr>
-              <a:t>officia</a:t>
-            </a:r>
-            <a:r>
-              <a:rPr sz="900" dirty="0">
-                <a:solidFill>
-                  <a:srgbClr val="2D3436"/>
-                </a:solidFill>
-              </a:rPr>
-              <a:t> </a:t>
-            </a:r>
-            <a:r>
-              <a:rPr sz="900" dirty="0" err="1">
-                <a:solidFill>
-                  <a:srgbClr val="2D3436"/>
-                </a:solidFill>
-              </a:rPr>
-              <a:t>deserunt</a:t>
-            </a:r>
-            <a:r>
-              <a:rPr sz="900" dirty="0">
-                <a:solidFill>
-                  <a:srgbClr val="2D3436"/>
-                </a:solidFill>
-              </a:rPr>
-              <a:t> </a:t>
-            </a:r>
-            <a:r>
-              <a:rPr sz="900" dirty="0" err="1">
-                <a:solidFill>
-                  <a:srgbClr val="2D3436"/>
-                </a:solidFill>
-              </a:rPr>
-              <a:t>mollit</a:t>
-            </a:r>
-            <a:r>
-              <a:rPr sz="900" dirty="0">
-                <a:solidFill>
-                  <a:srgbClr val="2D3436"/>
-                </a:solidFill>
-              </a:rPr>
-              <a:t> </a:t>
-            </a:r>
-            <a:r>
-              <a:rPr sz="900" dirty="0" err="1">
-                <a:solidFill>
-                  <a:srgbClr val="2D3436"/>
-                </a:solidFill>
-              </a:rPr>
-              <a:t>anim</a:t>
-            </a:r>
-            <a:r>
-              <a:rPr sz="900" dirty="0">
-                <a:solidFill>
-                  <a:srgbClr val="2D3436"/>
-                </a:solidFill>
-              </a:rPr>
-              <a:t> id </a:t>
-            </a:r>
-            <a:r>
-              <a:rPr sz="900" dirty="0" err="1">
-                <a:solidFill>
-                  <a:srgbClr val="2D3436"/>
-                </a:solidFill>
-              </a:rPr>
-              <a:t>est</a:t>
-            </a:r>
-            <a:r>
-              <a:rPr sz="900" dirty="0">
-                <a:solidFill>
-                  <a:srgbClr val="2D3436"/>
-                </a:solidFill>
-              </a:rPr>
-              <a:t> </a:t>
-            </a:r>
-            <a:r>
-              <a:rPr sz="900" dirty="0" err="1">
-                <a:solidFill>
-                  <a:srgbClr val="2D3436"/>
-                </a:solidFill>
-              </a:rPr>
-              <a:t>laborum</a:t>
-            </a:r>
-            <a:r>
-              <a:rPr sz="900" dirty="0">
-                <a:solidFill>
-                  <a:srgbClr val="2D3436"/>
-                </a:solidFill>
-              </a:rPr>
-              <a:t>. Sed </a:t>
-            </a:r>
-            <a:r>
-              <a:rPr sz="900" dirty="0" err="1">
-                <a:solidFill>
-                  <a:srgbClr val="2D3436"/>
-                </a:solidFill>
-              </a:rPr>
-              <a:t>ut</a:t>
-            </a:r>
-            <a:r>
-              <a:rPr sz="900" dirty="0">
-                <a:solidFill>
-                  <a:srgbClr val="2D3436"/>
-                </a:solidFill>
-              </a:rPr>
-              <a:t> </a:t>
-            </a:r>
-            <a:r>
-              <a:rPr sz="900" dirty="0" err="1">
-                <a:solidFill>
-                  <a:srgbClr val="2D3436"/>
-                </a:solidFill>
-              </a:rPr>
-              <a:t>perspiciatis</a:t>
-            </a:r>
-            <a:r>
-              <a:rPr sz="900" dirty="0">
-                <a:solidFill>
-                  <a:srgbClr val="2D3436"/>
-                </a:solidFill>
-              </a:rPr>
-              <a:t> </a:t>
-            </a:r>
-            <a:r>
-              <a:rPr sz="900" dirty="0" err="1">
-                <a:solidFill>
-                  <a:srgbClr val="2D3436"/>
-                </a:solidFill>
-              </a:rPr>
-              <a:t>unde</a:t>
-            </a:r>
-            <a:r>
-              <a:rPr sz="900" dirty="0">
-                <a:solidFill>
-                  <a:srgbClr val="2D3436"/>
-                </a:solidFill>
-              </a:rPr>
-              <a:t> </a:t>
-            </a:r>
-            <a:r>
-              <a:rPr sz="900" dirty="0" err="1">
-                <a:solidFill>
-                  <a:srgbClr val="2D3436"/>
-                </a:solidFill>
-              </a:rPr>
-              <a:t>omnis</a:t>
-            </a:r>
-            <a:r>
-              <a:rPr sz="900" dirty="0">
-                <a:solidFill>
-                  <a:srgbClr val="2D3436"/>
-                </a:solidFill>
-              </a:rPr>
-              <a:t> </a:t>
-            </a:r>
-            <a:r>
-              <a:rPr sz="900" dirty="0" err="1">
-                <a:solidFill>
-                  <a:srgbClr val="2D3436"/>
-                </a:solidFill>
-              </a:rPr>
-              <a:t>iste</a:t>
-            </a:r>
-            <a:r>
-              <a:rPr sz="900" dirty="0">
-                <a:solidFill>
-                  <a:srgbClr val="2D3436"/>
-                </a:solidFill>
-              </a:rPr>
-              <a:t> </a:t>
-            </a:r>
-            <a:r>
-              <a:rPr sz="900" dirty="0" err="1">
-                <a:solidFill>
-                  <a:srgbClr val="2D3436"/>
-                </a:solidFill>
-              </a:rPr>
-              <a:t>natus</a:t>
-            </a:r>
-            <a:r>
-              <a:rPr sz="900" dirty="0">
-                <a:solidFill>
-                  <a:srgbClr val="2D3436"/>
-                </a:solidFill>
-              </a:rPr>
-              <a:t> error sit </a:t>
-            </a:r>
-            <a:r>
-              <a:rPr sz="900" dirty="0" err="1">
-                <a:solidFill>
-                  <a:srgbClr val="2D3436"/>
-                </a:solidFill>
-              </a:rPr>
-              <a:t>voluptatem</a:t>
-            </a:r>
-            <a:r>
-              <a:rPr sz="900" dirty="0">
-                <a:solidFill>
-                  <a:srgbClr val="2D3436"/>
-                </a:solidFill>
-              </a:rPr>
-              <a:t>.</a:t>
-            </a:r>
-          </a:p>
-          <a:p>
-            <a:r>
-              <a:rPr sz="900" dirty="0">
-                <a:solidFill>
-                  <a:srgbClr val="2D3436"/>
-                </a:solidFill>
-              </a:rPr>
-              <a:t>Extra: This additional text should overflow into whichever column has space remaining, demonstrating the multi-column text flow behavior of OOXML </a:t>
-            </a:r>
-            <a:r>
-              <a:rPr sz="900" dirty="0" err="1">
-                <a:solidFill>
-                  <a:srgbClr val="2D3436"/>
-                </a:solidFill>
-              </a:rPr>
-              <a:t>bodyPr</a:t>
-            </a:r>
-            <a:r>
-              <a:rPr sz="900" dirty="0">
-                <a:solidFill>
-                  <a:srgbClr val="2D3436"/>
-                </a:solidFill>
-              </a:rPr>
-              <a:t> </a:t>
-            </a:r>
-            <a:r>
-              <a:rPr sz="900" dirty="0" err="1">
-                <a:solidFill>
-                  <a:srgbClr val="2D3436"/>
-                </a:solidFill>
-              </a:rPr>
-              <a:t>numCol</a:t>
-            </a:r>
-            <a:r>
-              <a:rPr sz="900" dirty="0">
-                <a:solidFill>
-                  <a:srgbClr val="2D3436"/>
-                </a:solidFill>
-              </a:rPr>
-              <a:t> attribute. Nam libero tempore.</a:t>
-            </a:r>
-          </a:p>
-          <a:p>
-            <a:r>
-              <a:rPr sz="900" dirty="0" err="1">
-                <a:solidFill>
-                  <a:srgbClr val="2D3436"/>
-                </a:solidFill>
-              </a:rPr>
-              <a:t>补充段落：多列文本是</a:t>
-            </a:r>
-            <a:r>
-              <a:rPr sz="900" dirty="0">
-                <a:solidFill>
-                  <a:srgbClr val="2D3436"/>
-                </a:solidFill>
-              </a:rPr>
-              <a:t> PowerPoint </a:t>
-            </a:r>
-            <a:r>
-              <a:rPr sz="900" dirty="0" err="1">
-                <a:solidFill>
-                  <a:srgbClr val="2D3436"/>
-                </a:solidFill>
-              </a:rPr>
-              <a:t>中一个实用的排版功能，常用于新闻、报纸、杂志风格的幻灯片设计，让内容更紧凑、更专业。此段文字用于确保三列均有内容填充</a:t>
-            </a:r>
-            <a:r>
-              <a:rPr sz="900" dirty="0">
-                <a:solidFill>
-                  <a:srgbClr val="2D3436"/>
-                </a:solidFill>
-              </a:rPr>
-              <a:t>。</a:t>
+              <a:rPr lang="en-US" sz="1600" dirty="0" err="1"/>
+              <a:t>中文说明</a:t>
+            </a:r>
+            <a:r>
+              <a:rPr lang="en-US" sz="1600" dirty="0"/>
+              <a:t> proves CJK wrapping.</a:t>
             </a:r>
           </a:p>
         </p:txBody>

</xml_diff>

<commit_message>
Deploy viewer examples from commit 91858de8 at 2026/07/01 16:01:53
</commit_message>
<xml_diff>
--- a/viewer-examples/samples/05-preview.pptx
+++ b/viewer-examples/samples/05-preview.pptx
@@ -13265,13 +13265,58 @@
           <a:lstStyle/>
           <a:p>
             <a:r>
-              <a:rPr sz="1100" i="1">
+              <a:rPr sz="1100" i="1" dirty="0">
                 <a:solidFill>
                   <a:srgbClr val="7F8C8D"/>
                 </a:solidFill>
               </a:rPr>
-              <a:t>Tests tooltip, hlinkMouseOver, and ppaction://hlinksldjump</a:t>
-            </a:r>
+              <a:t>Tests tooltip, </a:t>
+            </a:r>
+            <a:r>
+              <a:rPr sz="1100" i="1" dirty="0" err="1">
+                <a:solidFill>
+                  <a:srgbClr val="7F8C8D"/>
+                </a:solidFill>
+              </a:rPr>
+              <a:t>hlinkMouseOver</a:t>
+            </a:r>
+            <a:r>
+              <a:rPr sz="1100" i="1" dirty="0">
+                <a:solidFill>
+                  <a:srgbClr val="7F8C8D"/>
+                </a:solidFill>
+              </a:rPr>
+              <a:t>, and </a:t>
+            </a:r>
+            <a:r>
+              <a:rPr sz="1100" i="1" dirty="0" err="1">
+                <a:solidFill>
+                  <a:srgbClr val="7F8C8D"/>
+                </a:solidFill>
+              </a:rPr>
+              <a:t>ppaction</a:t>
+            </a:r>
+            <a:r>
+              <a:rPr sz="1100" i="1" dirty="0">
+                <a:solidFill>
+                  <a:srgbClr val="7F8C8D"/>
+                </a:solidFill>
+              </a:rPr>
+              <a:t>://</a:t>
+            </a:r>
+            <a:r>
+              <a:rPr sz="1100" i="1" dirty="0" err="1">
+                <a:solidFill>
+                  <a:srgbClr val="7F8C8D"/>
+                </a:solidFill>
+              </a:rPr>
+              <a:t>hlinksldjump</a:t>
+            </a:r>
+            <a:endParaRPr sz="1100" i="1" dirty="0">
+              <a:solidFill>
+                <a:srgbClr val="7F8C8D"/>
+              </a:solidFill>
+            </a:endParaRPr>
           </a:p>
         </p:txBody>
       </p:sp>
@@ -14396,12 +14441,44 @@
           <a:lstStyle/>
           <a:p>
             <a:r>
-              <a:rPr sz="1100" i="1">
+              <a:rPr sz="1100" i="1" dirty="0">
                 <a:solidFill>
                   <a:srgbClr val="7F8C8D"/>
                 </a:solidFill>
               </a:rPr>
-              <a:t>Tests a:tabLst / a:tab parsing (left / center / right / decimal)</a:t>
+              <a:t>Tests </a:t>
+            </a:r>
+            <a:r>
+              <a:rPr sz="1100" i="1" dirty="0" err="1">
+                <a:solidFill>
+                  <a:srgbClr val="7F8C8D"/>
+                </a:solidFill>
+              </a:rPr>
+              <a:t>a:tabLst</a:t>
+            </a:r>
+            <a:r>
+              <a:rPr sz="1100" i="1" dirty="0">
+                <a:solidFill>
+                  <a:srgbClr val="7F8C8D"/>
+                </a:solidFill>
+              </a:rPr>
+              <a:t> / </a:t>
+            </a:r>
+            <a:r>
+              <a:rPr sz="1100" i="1" dirty="0" err="1">
+                <a:solidFill>
+                  <a:srgbClr val="7F8C8D"/>
+                </a:solidFill>
+              </a:rPr>
+              <a:t>a:tab</a:t>
+            </a:r>
+            <a:r>
+              <a:rPr sz="1100" i="1" dirty="0">
+                <a:solidFill>
+                  <a:srgbClr val="7F8C8D"/>
+                </a:solidFill>
+              </a:rPr>
+              <a:t> parsing (left / center / right / decimal)</a:t>
             </a:r>
           </a:p>
         </p:txBody>
@@ -14897,8 +14974,8 @@
         </p:nvSpPr>
         <p:spPr>
           <a:xfrm>
-            <a:off x="1051560" y="658368"/>
-            <a:ext cx="7315200" cy="292608"/>
+            <a:off x="1051560" y="568718"/>
+            <a:ext cx="4211409" cy="276999"/>
           </a:xfrm>
           <a:prstGeom prst="rect">
             <a:avLst/>
@@ -14912,8 +14989,34 @@
           <a:lstStyle/>
           <a:p>
             <a:r>
-              <a:rPr lang="en-US"/>
-              <a:t>Tests a:pattFill rendering across common OOXML preset patterns</a:t>
+              <a:rPr lang="en-US" sz="1200" i="1" dirty="0">
+                <a:solidFill>
+                  <a:schemeClr val="bg1">
+                    <a:lumMod val="65000"/>
+                  </a:schemeClr>
+                </a:solidFill>
+              </a:rPr>
+              <a:t>Tests </a:t>
+            </a:r>
+            <a:r>
+              <a:rPr lang="en-US" sz="1200" i="1" dirty="0" err="1">
+                <a:solidFill>
+                  <a:schemeClr val="bg1">
+                    <a:lumMod val="65000"/>
+                  </a:schemeClr>
+                </a:solidFill>
+              </a:rPr>
+              <a:t>a:pattFill</a:t>
+            </a:r>
+            <a:r>
+              <a:rPr lang="en-US" sz="1200" i="1" dirty="0">
+                <a:solidFill>
+                  <a:schemeClr val="bg1">
+                    <a:lumMod val="65000"/>
+                  </a:schemeClr>
+                </a:solidFill>
+              </a:rPr>
+              <a:t> rendering across common OOXML preset patterns</a:t>
             </a:r>
           </a:p>
         </p:txBody>
@@ -15913,8 +16016,8 @@
         </p:nvSpPr>
         <p:spPr>
           <a:xfrm>
-            <a:off x="1051560" y="658368"/>
-            <a:ext cx="3156185" cy="276999"/>
+            <a:off x="1051560" y="586648"/>
+            <a:ext cx="3127716" cy="276999"/>
           </a:xfrm>
           <a:prstGeom prst="rect">
             <a:avLst/>
@@ -15928,7 +16031,13 @@
           <a:lstStyle/>
           <a:p>
             <a:r>
-              <a:rPr lang="en-US" sz="1200" dirty="0"/>
+              <a:rPr lang="en-US" sz="1200" i="1" dirty="0">
+                <a:solidFill>
+                  <a:schemeClr val="bg1">
+                    <a:lumMod val="65000"/>
+                  </a:schemeClr>
+                </a:solidFill>
+              </a:rPr>
               <a:t>This slide: push transition entering from the left</a:t>
             </a:r>
           </a:p>
@@ -16248,8 +16357,8 @@
         </p:nvSpPr>
         <p:spPr>
           <a:xfrm>
-            <a:off x="1051560" y="658368"/>
-            <a:ext cx="2744021" cy="276999"/>
+            <a:off x="1051560" y="595613"/>
+            <a:ext cx="2728055" cy="276999"/>
           </a:xfrm>
           <a:prstGeom prst="rect">
             <a:avLst/>
@@ -16263,15 +16372,33 @@
           <a:lstStyle/>
           <a:p>
             <a:r>
-              <a:rPr lang="en-US" sz="1200" dirty="0"/>
+              <a:rPr lang="en-US" sz="1200" i="1" dirty="0">
+                <a:solidFill>
+                  <a:schemeClr val="bg1">
+                    <a:lumMod val="65000"/>
+                  </a:schemeClr>
+                </a:solidFill>
+              </a:rPr>
               <a:t>Tests </a:t>
             </a:r>
             <a:r>
-              <a:rPr lang="en-US" sz="1200" dirty="0" err="1"/>
+              <a:rPr lang="en-US" sz="1200" i="1" dirty="0" err="1">
+                <a:solidFill>
+                  <a:schemeClr val="bg1">
+                    <a:lumMod val="65000"/>
+                  </a:schemeClr>
+                </a:solidFill>
+              </a:rPr>
               <a:t>clip.shape</a:t>
             </a:r>
             <a:r>
-              <a:rPr lang="en-US" sz="1200" dirty="0"/>
+              <a:rPr lang="en-US" sz="1200" i="1" dirty="0">
+                <a:solidFill>
+                  <a:schemeClr val="bg1">
+                    <a:lumMod val="65000"/>
+                  </a:schemeClr>
+                </a:solidFill>
+              </a:rPr>
               <a:t> to CSS clip-path mapping</a:t>
             </a:r>
           </a:p>
@@ -20566,8 +20693,8 @@
         </p:nvSpPr>
         <p:spPr>
           <a:xfrm>
-            <a:off x="1051560" y="658368"/>
-            <a:ext cx="7315200" cy="292608"/>
+            <a:off x="1051560" y="604578"/>
+            <a:ext cx="4745915" cy="276999"/>
           </a:xfrm>
           <a:prstGeom prst="rect">
             <a:avLst/>
@@ -20581,7 +20708,13 @@
           <a:lstStyle/>
           <a:p>
             <a:r>
-              <a:rPr lang="en-US"/>
+              <a:rPr lang="en-US" sz="1200" i="1" dirty="0">
+                <a:solidFill>
+                  <a:schemeClr val="bg1">
+                    <a:lumMod val="65000"/>
+                  </a:schemeClr>
+                </a:solidFill>
+              </a:rPr>
               <a:t>Validation for italic / underline / strikethrough / bold / color combinations</a:t>
             </a:r>
           </a:p>
@@ -20836,7 +20969,7 @@
                     <a:lstStyle/>
                     <a:p>
                       <a:r>
-                        <a:rPr sz="1100" b="1" i="1"/>
+                        <a:rPr sz="1100" b="1" i="1" dirty="0"/>
                         <a:t>Bold Italic Text</a:t>
                       </a:r>
                     </a:p>
@@ -21294,8 +21427,8 @@
         </p:nvSpPr>
         <p:spPr>
           <a:xfrm>
-            <a:off x="1051560" y="658368"/>
-            <a:ext cx="4458465" cy="307777"/>
+            <a:off x="1051560" y="568718"/>
+            <a:ext cx="3823547" cy="276999"/>
           </a:xfrm>
           <a:prstGeom prst="rect">
             <a:avLst/>
@@ -21309,23 +21442,53 @@
           <a:lstStyle/>
           <a:p>
             <a:r>
-              <a:rPr lang="en-US" sz="1400" dirty="0"/>
+              <a:rPr lang="en-US" sz="1200" i="1" dirty="0">
+                <a:solidFill>
+                  <a:schemeClr val="bg1">
+                    <a:lumMod val="65000"/>
+                  </a:schemeClr>
+                </a:solidFill>
+              </a:rPr>
               <a:t>Tests automatic filling of hf placeholders (</a:t>
             </a:r>
             <a:r>
-              <a:rPr lang="en-US" sz="1400" dirty="0" err="1"/>
+              <a:rPr lang="en-US" sz="1200" i="1" dirty="0" err="1">
+                <a:solidFill>
+                  <a:schemeClr val="bg1">
+                    <a:lumMod val="65000"/>
+                  </a:schemeClr>
+                </a:solidFill>
+              </a:rPr>
               <a:t>ftr</a:t>
             </a:r>
             <a:r>
-              <a:rPr lang="en-US" sz="1400" dirty="0"/>
+              <a:rPr lang="en-US" sz="1200" i="1" dirty="0">
+                <a:solidFill>
+                  <a:schemeClr val="bg1">
+                    <a:lumMod val="65000"/>
+                  </a:schemeClr>
+                </a:solidFill>
+              </a:rPr>
               <a:t> / </a:t>
             </a:r>
             <a:r>
-              <a:rPr lang="en-US" sz="1400" dirty="0" err="1"/>
+              <a:rPr lang="en-US" sz="1200" i="1" dirty="0" err="1">
+                <a:solidFill>
+                  <a:schemeClr val="bg1">
+                    <a:lumMod val="65000"/>
+                  </a:schemeClr>
+                </a:solidFill>
+              </a:rPr>
               <a:t>sldNum</a:t>
             </a:r>
             <a:r>
-              <a:rPr lang="en-US" sz="1400" dirty="0"/>
+              <a:rPr lang="en-US" sz="1200" i="1" dirty="0">
+                <a:solidFill>
+                  <a:schemeClr val="bg1">
+                    <a:lumMod val="65000"/>
+                  </a:schemeClr>
+                </a:solidFill>
+              </a:rPr>
               <a:t> / dt)</a:t>
             </a:r>
           </a:p>
@@ -21491,8 +21654,37 @@
           <a:lstStyle/>
           <a:p>
             <a:r>
-              <a:rPr lang="en-US" sz="1400"/>
-              <a:t>Footer (ftr)</a:t>
+              <a:rPr lang="en-US" sz="1400" dirty="0">
+                <a:solidFill>
+                  <a:schemeClr val="tx1">
+                    <a:lumMod val="50000"/>
+                    <a:lumOff val="50000"/>
+                  </a:schemeClr>
+                </a:solidFill>
+              </a:rPr>
+              <a:t>Footer (</a:t>
+            </a:r>
+            <a:r>
+              <a:rPr lang="en-US" sz="1400" dirty="0" err="1">
+                <a:solidFill>
+                  <a:schemeClr val="tx1">
+                    <a:lumMod val="50000"/>
+                    <a:lumOff val="50000"/>
+                  </a:schemeClr>
+                </a:solidFill>
+              </a:rPr>
+              <a:t>ftr</a:t>
+            </a:r>
+            <a:r>
+              <a:rPr lang="en-US" sz="1400" dirty="0">
+                <a:solidFill>
+                  <a:schemeClr val="tx1">
+                    <a:lumMod val="50000"/>
+                    <a:lumOff val="50000"/>
+                  </a:schemeClr>
+                </a:solidFill>
+              </a:rPr>
+              <a:t>)</a:t>
             </a:r>
           </a:p>
         </p:txBody>
@@ -21554,7 +21746,14 @@
           <a:lstStyle/>
           <a:p>
             <a:r>
-              <a:rPr lang="en-US" sz="1400" dirty="0"/>
+              <a:rPr lang="en-US" sz="1400" dirty="0">
+                <a:solidFill>
+                  <a:schemeClr val="tx1">
+                    <a:lumMod val="50000"/>
+                    <a:lumOff val="50000"/>
+                  </a:schemeClr>
+                </a:solidFill>
+              </a:rPr>
               <a:t>Footer text appears below</a:t>
             </a:r>
           </a:p>
@@ -21676,8 +21875,37 @@
           <a:lstStyle/>
           <a:p>
             <a:r>
-              <a:rPr lang="en-US" sz="1400"/>
-              <a:t>Slide Number (sldNum)</a:t>
+              <a:rPr lang="en-US" sz="1400" dirty="0">
+                <a:solidFill>
+                  <a:schemeClr val="tx1">
+                    <a:lumMod val="50000"/>
+                    <a:lumOff val="50000"/>
+                  </a:schemeClr>
+                </a:solidFill>
+              </a:rPr>
+              <a:t>Slide Number (</a:t>
+            </a:r>
+            <a:r>
+              <a:rPr lang="en-US" sz="1400" dirty="0" err="1">
+                <a:solidFill>
+                  <a:schemeClr val="tx1">
+                    <a:lumMod val="50000"/>
+                    <a:lumOff val="50000"/>
+                  </a:schemeClr>
+                </a:solidFill>
+              </a:rPr>
+              <a:t>sldNum</a:t>
+            </a:r>
+            <a:r>
+              <a:rPr lang="en-US" sz="1400" dirty="0">
+                <a:solidFill>
+                  <a:schemeClr val="tx1">
+                    <a:lumMod val="50000"/>
+                    <a:lumOff val="50000"/>
+                  </a:schemeClr>
+                </a:solidFill>
+              </a:rPr>
+              <a:t>)</a:t>
             </a:r>
           </a:p>
         </p:txBody>
@@ -21739,7 +21967,14 @@
           <a:lstStyle/>
           <a:p>
             <a:r>
-              <a:rPr lang="en-US" sz="1400"/>
+              <a:rPr lang="en-US" sz="1400" dirty="0">
+                <a:solidFill>
+                  <a:schemeClr val="tx1">
+                    <a:lumMod val="50000"/>
+                    <a:lumOff val="50000"/>
+                  </a:schemeClr>
+                </a:solidFill>
+              </a:rPr>
               <a:t>Current slide number</a:t>
             </a:r>
           </a:p>
@@ -21861,7 +22096,14 @@
           <a:lstStyle/>
           <a:p>
             <a:r>
-              <a:rPr lang="en-US" sz="1400"/>
+              <a:rPr lang="en-US" sz="1400" dirty="0">
+                <a:solidFill>
+                  <a:schemeClr val="tx1">
+                    <a:lumMod val="50000"/>
+                    <a:lumOff val="50000"/>
+                  </a:schemeClr>
+                </a:solidFill>
+              </a:rPr>
               <a:t>Date (dt)</a:t>
             </a:r>
           </a:p>
@@ -21924,7 +22166,14 @@
           <a:lstStyle/>
           <a:p>
             <a:r>
-              <a:rPr lang="en-US" sz="1400"/>
+              <a:rPr lang="en-US" sz="1400" dirty="0">
+                <a:solidFill>
+                  <a:schemeClr val="tx1">
+                    <a:lumMod val="50000"/>
+                    <a:lumOff val="50000"/>
+                  </a:schemeClr>
+                </a:solidFill>
+              </a:rPr>
               <a:t>Fixed or auto date</a:t>
             </a:r>
           </a:p>
@@ -22170,8 +22419,8 @@
         </p:nvSpPr>
         <p:spPr>
           <a:xfrm>
-            <a:off x="1051560" y="658368"/>
-            <a:ext cx="4330481" cy="307777"/>
+            <a:off x="1051560" y="613543"/>
+            <a:ext cx="3707810" cy="276999"/>
           </a:xfrm>
           <a:prstGeom prst="rect">
             <a:avLst/>
@@ -22185,30 +22434,72 @@
           <a:lstStyle/>
           <a:p>
             <a:r>
-              <a:rPr lang="en-US" sz="1400" dirty="0"/>
+              <a:rPr lang="en-US" sz="1200" i="1" dirty="0">
+                <a:solidFill>
+                  <a:schemeClr val="bg1">
+                    <a:lumMod val="65000"/>
+                  </a:schemeClr>
+                </a:solidFill>
+              </a:rPr>
               <a:t>CJK + English mixed layout using </a:t>
             </a:r>
             <a:r>
-              <a:rPr lang="en-US" sz="1400" dirty="0" err="1"/>
+              <a:rPr lang="en-US" sz="1200" i="1" dirty="0" err="1">
+                <a:solidFill>
+                  <a:schemeClr val="bg1">
+                    <a:lumMod val="65000"/>
+                  </a:schemeClr>
+                </a:solidFill>
+              </a:rPr>
               <a:t>bodyPr</a:t>
             </a:r>
             <a:r>
-              <a:rPr lang="en-US" sz="1400" dirty="0"/>
+              <a:rPr lang="en-US" sz="1200" i="1" dirty="0">
+                <a:solidFill>
+                  <a:schemeClr val="bg1">
+                    <a:lumMod val="65000"/>
+                  </a:schemeClr>
+                </a:solidFill>
+              </a:rPr>
               <a:t> </a:t>
             </a:r>
             <a:r>
-              <a:rPr lang="en-US" sz="1400" dirty="0" err="1"/>
+              <a:rPr lang="en-US" sz="1200" i="1" dirty="0" err="1">
+                <a:solidFill>
+                  <a:schemeClr val="bg1">
+                    <a:lumMod val="65000"/>
+                  </a:schemeClr>
+                </a:solidFill>
+              </a:rPr>
               <a:t>numCol</a:t>
             </a:r>
             <a:r>
-              <a:rPr lang="en-US" sz="1400" dirty="0"/>
+              <a:rPr lang="en-US" sz="1200" i="1" dirty="0">
+                <a:solidFill>
+                  <a:schemeClr val="bg1">
+                    <a:lumMod val="65000"/>
+                  </a:schemeClr>
+                </a:solidFill>
+              </a:rPr>
               <a:t> + </a:t>
             </a:r>
             <a:r>
-              <a:rPr lang="en-US" sz="1400" dirty="0" err="1"/>
+              <a:rPr lang="en-US" sz="1200" i="1" dirty="0" err="1">
+                <a:solidFill>
+                  <a:schemeClr val="bg1">
+                    <a:lumMod val="65000"/>
+                  </a:schemeClr>
+                </a:solidFill>
+              </a:rPr>
               <a:t>spcCol</a:t>
             </a:r>
-            <a:endParaRPr lang="en-US" sz="1400" dirty="0"/>
+            <a:endParaRPr lang="en-US" sz="1200" i="1" dirty="0">
+              <a:solidFill>
+                <a:schemeClr val="bg1">
+                  <a:lumMod val="65000"/>
+                </a:schemeClr>
+              </a:solidFill>
+            </a:endParaRPr>
           </a:p>
         </p:txBody>
       </p:sp>
@@ -22354,53 +22645,137 @@
           <a:lstStyle/>
           <a:p>
             <a:r>
-              <a:rPr lang="en-US" sz="1600" dirty="0"/>
+              <a:rPr lang="en-US" sz="1400" dirty="0">
+                <a:solidFill>
+                  <a:schemeClr val="tx1">
+                    <a:lumMod val="50000"/>
+                    <a:lumOff val="50000"/>
+                  </a:schemeClr>
+                </a:solidFill>
+              </a:rPr>
               <a:t>English text verifies two-column flow. Overflow should continue in the next column with a visible </a:t>
             </a:r>
             <a:r>
-              <a:rPr lang="en-US" sz="1600" dirty="0" err="1"/>
+              <a:rPr lang="en-US" sz="1400" dirty="0" err="1">
+                <a:solidFill>
+                  <a:schemeClr val="tx1">
+                    <a:lumMod val="50000"/>
+                    <a:lumOff val="50000"/>
+                  </a:schemeClr>
+                </a:solidFill>
+              </a:rPr>
               <a:t>spcCol</a:t>
             </a:r>
             <a:r>
-              <a:rPr lang="en-US" sz="1600" dirty="0"/>
+              <a:rPr lang="en-US" sz="1400" dirty="0">
+                <a:solidFill>
+                  <a:schemeClr val="tx1">
+                    <a:lumMod val="50000"/>
+                    <a:lumOff val="50000"/>
+                  </a:schemeClr>
+                </a:solidFill>
+              </a:rPr>
               <a:t> gap.</a:t>
             </a:r>
           </a:p>
           <a:p>
-            <a:endParaRPr lang="en-US" sz="1600" dirty="0"/>
-          </a:p>
-          <a:p>
-            <a:endParaRPr lang="en-US" sz="1600" dirty="0"/>
-          </a:p>
-          <a:p>
-            <a:r>
-              <a:rPr lang="en-US" sz="1600" dirty="0" err="1"/>
+            <a:endParaRPr lang="en-US" sz="1600" dirty="0">
+              <a:solidFill>
+                <a:schemeClr val="tx1">
+                  <a:lumMod val="50000"/>
+                  <a:lumOff val="50000"/>
+                </a:schemeClr>
+              </a:solidFill>
+            </a:endParaRPr>
+          </a:p>
+          <a:p>
+            <a:endParaRPr lang="en-US" sz="1600" dirty="0">
+              <a:solidFill>
+                <a:schemeClr val="tx1">
+                  <a:lumMod val="50000"/>
+                  <a:lumOff val="50000"/>
+                </a:schemeClr>
+              </a:solidFill>
+            </a:endParaRPr>
+          </a:p>
+          <a:p>
+            <a:r>
+              <a:rPr lang="en-US" sz="1400" dirty="0" err="1">
+                <a:solidFill>
+                  <a:schemeClr val="tx1">
+                    <a:lumMod val="50000"/>
+                    <a:lumOff val="50000"/>
+                  </a:schemeClr>
+                </a:solidFill>
+              </a:rPr>
               <a:t>中文混排：验证</a:t>
             </a:r>
             <a:r>
-              <a:rPr lang="en-US" sz="1600" dirty="0"/>
+              <a:rPr lang="en-US" sz="1400" dirty="0">
+                <a:solidFill>
+                  <a:schemeClr val="tx1">
+                    <a:lumMod val="50000"/>
+                    <a:lumOff val="50000"/>
+                  </a:schemeClr>
+                </a:solidFill>
+              </a:rPr>
               <a:t> CJK </a:t>
             </a:r>
             <a:r>
-              <a:rPr lang="en-US" sz="1600" dirty="0" err="1"/>
+              <a:rPr lang="en-US" sz="1400" dirty="0" err="1">
+                <a:solidFill>
+                  <a:schemeClr val="tx1">
+                    <a:lumMod val="50000"/>
+                    <a:lumOff val="50000"/>
+                  </a:schemeClr>
+                </a:solidFill>
+              </a:rPr>
               <a:t>字体</a:t>
             </a:r>
             <a:r>
-              <a:rPr lang="en-US" sz="1600" dirty="0"/>
+              <a:rPr lang="en-US" sz="1400" dirty="0">
+                <a:solidFill>
+                  <a:schemeClr val="tx1">
+                    <a:lumMod val="50000"/>
+                    <a:lumOff val="50000"/>
+                  </a:schemeClr>
+                </a:solidFill>
+              </a:rPr>
               <a:t>。</a:t>
             </a:r>
           </a:p>
           <a:p>
             <a:r>
-              <a:rPr lang="en-US" sz="1600" dirty="0"/>
+              <a:rPr lang="en-US" sz="1400" dirty="0">
+                <a:solidFill>
+                  <a:schemeClr val="tx1">
+                    <a:lumMod val="50000"/>
+                    <a:lumOff val="50000"/>
+                  </a:schemeClr>
+                </a:solidFill>
+              </a:rPr>
               <a:t>Mixed English + </a:t>
             </a:r>
             <a:r>
-              <a:rPr lang="en-US" sz="1600" dirty="0" err="1"/>
+              <a:rPr lang="en-US" sz="1400" dirty="0" err="1">
+                <a:solidFill>
+                  <a:schemeClr val="tx1">
+                    <a:lumMod val="50000"/>
+                    <a:lumOff val="50000"/>
+                  </a:schemeClr>
+                </a:solidFill>
+              </a:rPr>
               <a:t>中文</a:t>
             </a:r>
             <a:r>
-              <a:rPr lang="en-US" sz="1600" dirty="0"/>
+              <a:rPr lang="en-US" sz="1400" dirty="0">
+                <a:solidFill>
+                  <a:schemeClr val="tx1">
+                    <a:lumMod val="50000"/>
+                    <a:lumOff val="50000"/>
+                  </a:schemeClr>
+                </a:solidFill>
+              </a:rPr>
               <a:t> should wrap without clipping.</a:t>
             </a:r>
           </a:p>
@@ -22504,33 +22879,82 @@
           <a:lstStyle/>
           <a:p>
             <a:r>
-              <a:rPr lang="en-US" sz="1600" dirty="0"/>
+              <a:rPr lang="en-US" sz="1600" dirty="0">
+                <a:solidFill>
+                  <a:schemeClr val="tx1">
+                    <a:lumMod val="50000"/>
+                    <a:lumOff val="50000"/>
+                  </a:schemeClr>
+                </a:solidFill>
+              </a:rPr>
               <a:t>Column 1: concise English text.</a:t>
             </a:r>
           </a:p>
           <a:p>
-            <a:endParaRPr lang="en-US" sz="1600" dirty="0"/>
-          </a:p>
-          <a:p>
-            <a:r>
-              <a:rPr lang="en-US" sz="1600" dirty="0"/>
+            <a:endParaRPr lang="en-US" sz="1600" dirty="0">
+              <a:solidFill>
+                <a:schemeClr val="tx1">
+                  <a:lumMod val="50000"/>
+                  <a:lumOff val="50000"/>
+                </a:schemeClr>
+              </a:solidFill>
+            </a:endParaRPr>
+          </a:p>
+          <a:p>
+            <a:r>
+              <a:rPr lang="en-US" sz="1600" dirty="0">
+                <a:solidFill>
+                  <a:schemeClr val="tx1">
+                    <a:lumMod val="50000"/>
+                    <a:lumOff val="50000"/>
+                  </a:schemeClr>
+                </a:solidFill>
+              </a:rPr>
               <a:t>Column 2: renderer keeps column spacing.</a:t>
             </a:r>
           </a:p>
           <a:p>
-            <a:endParaRPr lang="en-US" sz="1600" dirty="0"/>
-          </a:p>
-          <a:p>
-            <a:r>
-              <a:rPr lang="en-US" sz="1600" dirty="0"/>
+            <a:endParaRPr lang="en-US" sz="1600" dirty="0">
+              <a:solidFill>
+                <a:schemeClr val="tx1">
+                  <a:lumMod val="50000"/>
+                  <a:lumOff val="50000"/>
+                </a:schemeClr>
+              </a:solidFill>
+            </a:endParaRPr>
+          </a:p>
+          <a:p>
+            <a:r>
+              <a:rPr lang="en-US" sz="1600" dirty="0">
+                <a:solidFill>
+                  <a:schemeClr val="tx1">
+                    <a:lumMod val="50000"/>
+                    <a:lumOff val="50000"/>
+                  </a:schemeClr>
+                </a:solidFill>
+              </a:rPr>
               <a:t>Column 3: </a:t>
             </a:r>
             <a:r>
-              <a:rPr lang="en-US" sz="1600" dirty="0" err="1"/>
+              <a:rPr lang="en-US" sz="1600" dirty="0" err="1">
+                <a:solidFill>
+                  <a:schemeClr val="tx1">
+                    <a:lumMod val="50000"/>
+                    <a:lumOff val="50000"/>
+                  </a:schemeClr>
+                </a:solidFill>
+              </a:rPr>
               <a:t>中文说明</a:t>
             </a:r>
             <a:r>
-              <a:rPr lang="en-US" sz="1600" dirty="0"/>
+              <a:rPr lang="en-US" sz="1600" dirty="0">
+                <a:solidFill>
+                  <a:schemeClr val="tx1">
+                    <a:lumMod val="50000"/>
+                    <a:lumOff val="50000"/>
+                  </a:schemeClr>
+                </a:solidFill>
+              </a:rPr>
               <a:t> proves CJK wrapping.</a:t>
             </a:r>
           </a:p>

</xml_diff>